<commit_message>
content: make the introduction deck copy more factual
</commit_message>
<xml_diff>
--- a/decks/00-course-introduction.pptx
+++ b/decks/00-course-introduction.pptx
@@ -2,24 +2,24 @@
 <file path=ppt/presentation.xml><?xml version="1.0" encoding="utf-8"?>
 <p:presentation xmlns:p="http://schemas.openxmlformats.org/presentationml/2006/main">
   <p:sldMasterIdLst>
-    <p:sldMasterId xmlns:r="http://schemas.openxmlformats.org/officeDocument/2006/relationships" id="2147483648" r:id="Rae3dbd7564d04e5c"/>
+    <p:sldMasterId xmlns:r="http://schemas.openxmlformats.org/officeDocument/2006/relationships" id="2147483648" r:id="R5925d3c7253f40cc"/>
   </p:sldMasterIdLst>
   <p:notesMasterIdLst>
-    <p:notesMasterId xmlns:r="http://schemas.openxmlformats.org/officeDocument/2006/relationships" r:id="Rb6b92395d5c24fef"/>
+    <p:notesMasterId xmlns:r="http://schemas.openxmlformats.org/officeDocument/2006/relationships" r:id="Rdca6dfa62bbb4066"/>
   </p:notesMasterIdLst>
   <p:sldIdLst>
-    <p:sldId xmlns:r="http://schemas.openxmlformats.org/officeDocument/2006/relationships" id="256" r:id="R9b906b07bac34c95"/>
-    <p:sldId xmlns:r="http://schemas.openxmlformats.org/officeDocument/2006/relationships" id="257" r:id="Rc560a161da29478a"/>
-    <p:sldId xmlns:r="http://schemas.openxmlformats.org/officeDocument/2006/relationships" id="258" r:id="R6637ce18ab4e4429"/>
-    <p:sldId xmlns:r="http://schemas.openxmlformats.org/officeDocument/2006/relationships" id="259" r:id="R510cb6d4314b490d"/>
-    <p:sldId xmlns:r="http://schemas.openxmlformats.org/officeDocument/2006/relationships" id="260" r:id="R0b2d5a6579084289"/>
-    <p:sldId xmlns:r="http://schemas.openxmlformats.org/officeDocument/2006/relationships" id="261" r:id="Raeaab119bef8440f"/>
-    <p:sldId xmlns:r="http://schemas.openxmlformats.org/officeDocument/2006/relationships" id="262" r:id="Ra3c3f2d948d84497"/>
-    <p:sldId xmlns:r="http://schemas.openxmlformats.org/officeDocument/2006/relationships" id="263" r:id="R2a2141743d6f4566"/>
-    <p:sldId xmlns:r="http://schemas.openxmlformats.org/officeDocument/2006/relationships" id="264" r:id="Ra5eca003a2bd4b14"/>
-    <p:sldId xmlns:r="http://schemas.openxmlformats.org/officeDocument/2006/relationships" id="265" r:id="R66fa80adc36441f1"/>
-    <p:sldId xmlns:r="http://schemas.openxmlformats.org/officeDocument/2006/relationships" id="266" r:id="R4c3e0f02271046bb"/>
-    <p:sldId xmlns:r="http://schemas.openxmlformats.org/officeDocument/2006/relationships" id="267" r:id="Rd08db1ae731c4d4a"/>
+    <p:sldId xmlns:r="http://schemas.openxmlformats.org/officeDocument/2006/relationships" id="256" r:id="Reacb34acabb948fe"/>
+    <p:sldId xmlns:r="http://schemas.openxmlformats.org/officeDocument/2006/relationships" id="257" r:id="Ra6fab363ad764251"/>
+    <p:sldId xmlns:r="http://schemas.openxmlformats.org/officeDocument/2006/relationships" id="258" r:id="R9a0f8f9bf42a4c60"/>
+    <p:sldId xmlns:r="http://schemas.openxmlformats.org/officeDocument/2006/relationships" id="259" r:id="R23c004ae62794040"/>
+    <p:sldId xmlns:r="http://schemas.openxmlformats.org/officeDocument/2006/relationships" id="260" r:id="Ra6472fc7b471465d"/>
+    <p:sldId xmlns:r="http://schemas.openxmlformats.org/officeDocument/2006/relationships" id="261" r:id="Rae3d6a6e7664456f"/>
+    <p:sldId xmlns:r="http://schemas.openxmlformats.org/officeDocument/2006/relationships" id="262" r:id="R3662417c4df64e98"/>
+    <p:sldId xmlns:r="http://schemas.openxmlformats.org/officeDocument/2006/relationships" id="263" r:id="R5018f2292dcd4a1e"/>
+    <p:sldId xmlns:r="http://schemas.openxmlformats.org/officeDocument/2006/relationships" id="264" r:id="R853672f8c9234061"/>
+    <p:sldId xmlns:r="http://schemas.openxmlformats.org/officeDocument/2006/relationships" id="265" r:id="Rf9d63c53da004aa8"/>
+    <p:sldId xmlns:r="http://schemas.openxmlformats.org/officeDocument/2006/relationships" id="266" r:id="Ra981567327bd4dd7"/>
+    <p:sldId xmlns:r="http://schemas.openxmlformats.org/officeDocument/2006/relationships" id="267" r:id="Ra2810046195b4ac4"/>
   </p:sldIdLst>
   <p:sldSz cx="12192000" cy="6858000"/>
   <p:notesSz cx="6858000" cy="9144000"/>
@@ -1486,7 +1486,7 @@
   </p:cSld>
   <p:clrMap bg1="lt1" tx1="dk1" bg2="lt2" tx2="dk2" accent1="accent1" accent2="accent2" accent3="accent3" accent4="accent4" accent5="accent5" accent6="accent6" hlink="hlink" folHlink="folHlink"/>
   <p:sldLayoutIdLst>
-    <p:sldLayoutId xmlns:r="http://schemas.openxmlformats.org/officeDocument/2006/relationships" id="2147483649" r:id="R59762df1dca04a83"/>
+    <p:sldLayoutId xmlns:r="http://schemas.openxmlformats.org/officeDocument/2006/relationships" id="2147483649" r:id="R6340d5ffaae74ac3"/>
   </p:sldLayoutIdLst>
   <p:txStyles>
     <p:titleStyle>
@@ -2096,6 +2096,7 @@
           <a:lstStyle xmlns:a="http://schemas.openxmlformats.org/drawingml/2006/main"/>
           <a:p xmlns:a="http://schemas.openxmlformats.org/drawingml/2006/main">
             <a:pPr algn="l">
+              <a:buNone/>
               <a:defRPr sz="1125" b="1">
                 <a:solidFill>
                   <a:srgbClr val="00A2EB"/>
@@ -2146,6 +2147,7 @@
           <a:lstStyle xmlns:a="http://schemas.openxmlformats.org/drawingml/2006/main"/>
           <a:p xmlns:a="http://schemas.openxmlformats.org/drawingml/2006/main">
             <a:pPr algn="l">
+              <a:buNone/>
               <a:defRPr sz="4125" b="1">
                 <a:solidFill>
                   <a:srgbClr val="FFFFFF"/>
@@ -2163,6 +2165,7 @@
           </a:p>
           <a:p xmlns:a="http://schemas.openxmlformats.org/drawingml/2006/main">
             <a:pPr algn="l">
+              <a:buNone/>
               <a:defRPr sz="4125" b="1">
                 <a:solidFill>
                   <a:srgbClr val="FFFFFF"/>
@@ -2213,6 +2216,7 @@
           <a:lstStyle xmlns:a="http://schemas.openxmlformats.org/drawingml/2006/main"/>
           <a:p xmlns:a="http://schemas.openxmlformats.org/drawingml/2006/main">
             <a:pPr algn="l">
+              <a:buNone/>
               <a:defRPr sz="1875" b="0">
                 <a:solidFill>
                   <a:srgbClr val="F5F5F5"/>
@@ -2225,7 +2229,7 @@
                   <a:srgbClr val="F5F5F5"/>
                 </a:solidFill>
               </a:rPr>
-              <a:t>Build a Financial Analyst Copilot in Two Days</a:t>
+              <a:t>Two-day technical course and capstone project</a:t>
             </a:r>
           </a:p>
         </p:txBody>
@@ -2263,6 +2267,7 @@
           <a:lstStyle xmlns:a="http://schemas.openxmlformats.org/drawingml/2006/main"/>
           <a:p xmlns:a="http://schemas.openxmlformats.org/drawingml/2006/main">
             <a:pPr algn="l">
+              <a:buNone/>
               <a:defRPr sz="1350" b="0">
                 <a:solidFill>
                   <a:srgbClr val="9E9FA2"/>
@@ -2313,6 +2318,7 @@
           <a:lstStyle xmlns:a="http://schemas.openxmlformats.org/drawingml/2006/main"/>
           <a:p xmlns:a="http://schemas.openxmlformats.org/drawingml/2006/main">
             <a:pPr algn="r">
+              <a:buNone/>
               <a:defRPr sz="1200" b="1">
                 <a:solidFill>
                   <a:srgbClr val="F07D00"/>
@@ -2392,6 +2398,7 @@
           <a:lstStyle xmlns:a="http://schemas.openxmlformats.org/drawingml/2006/main"/>
           <a:p xmlns:a="http://schemas.openxmlformats.org/drawingml/2006/main">
             <a:pPr algn="l">
+              <a:buNone/>
               <a:defRPr sz="1050" b="1">
                 <a:solidFill>
                   <a:srgbClr val="1F40CB"/>
@@ -2442,6 +2449,7 @@
           <a:lstStyle xmlns:a="http://schemas.openxmlformats.org/drawingml/2006/main"/>
           <a:p xmlns:a="http://schemas.openxmlformats.org/drawingml/2006/main">
             <a:pPr algn="l">
+              <a:buNone/>
               <a:defRPr sz="2925" b="1">
                 <a:solidFill>
                   <a:srgbClr val="051C2A"/>
@@ -2554,6 +2562,7 @@
           <a:lstStyle xmlns:a="http://schemas.openxmlformats.org/drawingml/2006/main"/>
           <a:p xmlns:a="http://schemas.openxmlformats.org/drawingml/2006/main">
             <a:pPr algn="l">
+              <a:buNone/>
               <a:defRPr sz="975" b="0">
                 <a:solidFill>
                   <a:srgbClr val="9E9FA2"/>
@@ -2566,7 +2575,7 @@
                   <a:srgbClr val="9E9FA2"/>
                 </a:solidFill>
               </a:rPr>
-              <a:t>FinAI Academy — Arnaud Demes</a:t>
+              <a:t>First Finance - Arnaud Demes</a:t>
             </a:r>
           </a:p>
         </p:txBody>
@@ -2604,6 +2613,7 @@
           <a:lstStyle xmlns:a="http://schemas.openxmlformats.org/drawingml/2006/main"/>
           <a:p xmlns:a="http://schemas.openxmlformats.org/drawingml/2006/main">
             <a:pPr algn="r">
+              <a:buNone/>
               <a:defRPr sz="900" b="1">
                 <a:solidFill>
                   <a:srgbClr val="9E9FA2"/>
@@ -2654,6 +2664,7 @@
           <a:lstStyle xmlns:a="http://schemas.openxmlformats.org/drawingml/2006/main"/>
           <a:p xmlns:a="http://schemas.openxmlformats.org/drawingml/2006/main">
             <a:pPr algn="r">
+              <a:buNone/>
               <a:defRPr sz="900" b="1">
                 <a:solidFill>
                   <a:srgbClr val="9E9FA2"/>
@@ -2735,6 +2746,7 @@
           <a:lstStyle xmlns:a="http://schemas.openxmlformats.org/drawingml/2006/main"/>
           <a:p xmlns:a="http://schemas.openxmlformats.org/drawingml/2006/main">
             <a:pPr algn="l">
+              <a:buNone/>
               <a:defRPr sz="1275" b="1">
                 <a:solidFill>
                   <a:srgbClr val="1F40CB"/>
@@ -2818,6 +2830,7 @@
           <a:lstStyle xmlns:a="http://schemas.openxmlformats.org/drawingml/2006/main"/>
           <a:p xmlns:a="http://schemas.openxmlformats.org/drawingml/2006/main">
             <a:pPr algn="l">
+              <a:buNone/>
               <a:defRPr sz="1500" b="1">
                 <a:solidFill>
                   <a:srgbClr val="051C2A"/>
@@ -2868,6 +2881,7 @@
           <a:lstStyle xmlns:a="http://schemas.openxmlformats.org/drawingml/2006/main"/>
           <a:p xmlns:a="http://schemas.openxmlformats.org/drawingml/2006/main">
             <a:pPr algn="r">
+              <a:buNone/>
               <a:defRPr sz="1125" b="0">
                 <a:solidFill>
                   <a:srgbClr val="9E9FA2"/>
@@ -2918,6 +2932,7 @@
           <a:lstStyle xmlns:a="http://schemas.openxmlformats.org/drawingml/2006/main"/>
           <a:p xmlns:a="http://schemas.openxmlformats.org/drawingml/2006/main">
             <a:pPr algn="l">
+              <a:buNone/>
               <a:defRPr sz="1275" b="1">
                 <a:solidFill>
                   <a:srgbClr val="373738"/>
@@ -3001,6 +3016,7 @@
           <a:lstStyle xmlns:a="http://schemas.openxmlformats.org/drawingml/2006/main"/>
           <a:p xmlns:a="http://schemas.openxmlformats.org/drawingml/2006/main">
             <a:pPr algn="l">
+              <a:buNone/>
               <a:defRPr sz="1500" b="1">
                 <a:solidFill>
                   <a:srgbClr val="051C2A"/>
@@ -3051,6 +3067,7 @@
           <a:lstStyle xmlns:a="http://schemas.openxmlformats.org/drawingml/2006/main"/>
           <a:p xmlns:a="http://schemas.openxmlformats.org/drawingml/2006/main">
             <a:pPr algn="r">
+              <a:buNone/>
               <a:defRPr sz="1125" b="0">
                 <a:solidFill>
                   <a:srgbClr val="9E9FA2"/>
@@ -3101,6 +3118,7 @@
           <a:lstStyle xmlns:a="http://schemas.openxmlformats.org/drawingml/2006/main"/>
           <a:p xmlns:a="http://schemas.openxmlformats.org/drawingml/2006/main">
             <a:pPr algn="l">
+              <a:buNone/>
               <a:defRPr sz="1275" b="1">
                 <a:solidFill>
                   <a:srgbClr val="373738"/>
@@ -3184,6 +3202,7 @@
           <a:lstStyle xmlns:a="http://schemas.openxmlformats.org/drawingml/2006/main"/>
           <a:p xmlns:a="http://schemas.openxmlformats.org/drawingml/2006/main">
             <a:pPr algn="l">
+              <a:buNone/>
               <a:defRPr sz="1500" b="1">
                 <a:solidFill>
                   <a:srgbClr val="051C2A"/>
@@ -3234,6 +3253,7 @@
           <a:lstStyle xmlns:a="http://schemas.openxmlformats.org/drawingml/2006/main"/>
           <a:p xmlns:a="http://schemas.openxmlformats.org/drawingml/2006/main">
             <a:pPr algn="r">
+              <a:buNone/>
               <a:defRPr sz="1125" b="0">
                 <a:solidFill>
                   <a:srgbClr val="9E9FA2"/>
@@ -3284,6 +3304,7 @@
           <a:lstStyle xmlns:a="http://schemas.openxmlformats.org/drawingml/2006/main"/>
           <a:p xmlns:a="http://schemas.openxmlformats.org/drawingml/2006/main">
             <a:pPr algn="l">
+              <a:buNone/>
               <a:defRPr sz="1275" b="1">
                 <a:solidFill>
                   <a:srgbClr val="373738"/>
@@ -3367,6 +3388,7 @@
           <a:lstStyle xmlns:a="http://schemas.openxmlformats.org/drawingml/2006/main"/>
           <a:p xmlns:a="http://schemas.openxmlformats.org/drawingml/2006/main">
             <a:pPr algn="l">
+              <a:buNone/>
               <a:defRPr sz="1500" b="1">
                 <a:solidFill>
                   <a:srgbClr val="051C2A"/>
@@ -3417,6 +3439,7 @@
           <a:lstStyle xmlns:a="http://schemas.openxmlformats.org/drawingml/2006/main"/>
           <a:p xmlns:a="http://schemas.openxmlformats.org/drawingml/2006/main">
             <a:pPr algn="r">
+              <a:buNone/>
               <a:defRPr sz="1125" b="0">
                 <a:solidFill>
                   <a:srgbClr val="9E9FA2"/>
@@ -3467,6 +3490,7 @@
           <a:lstStyle xmlns:a="http://schemas.openxmlformats.org/drawingml/2006/main"/>
           <a:p xmlns:a="http://schemas.openxmlformats.org/drawingml/2006/main">
             <a:pPr algn="l">
+              <a:buNone/>
               <a:defRPr sz="1050" b="1">
                 <a:solidFill>
                   <a:srgbClr val="F07D00"/>
@@ -3517,6 +3541,7 @@
           <a:lstStyle xmlns:a="http://schemas.openxmlformats.org/drawingml/2006/main"/>
           <a:p xmlns:a="http://schemas.openxmlformats.org/drawingml/2006/main">
             <a:pPr algn="l">
+              <a:buNone/>
               <a:defRPr sz="1575" b="1">
                 <a:solidFill>
                   <a:srgbClr val="051C2A"/>
@@ -3596,6 +3621,7 @@
           <a:lstStyle xmlns:a="http://schemas.openxmlformats.org/drawingml/2006/main"/>
           <a:p xmlns:a="http://schemas.openxmlformats.org/drawingml/2006/main">
             <a:pPr algn="l">
+              <a:buNone/>
               <a:defRPr sz="1050" b="1">
                 <a:solidFill>
                   <a:srgbClr val="1F40CB"/>
@@ -3646,6 +3672,7 @@
           <a:lstStyle xmlns:a="http://schemas.openxmlformats.org/drawingml/2006/main"/>
           <a:p xmlns:a="http://schemas.openxmlformats.org/drawingml/2006/main">
             <a:pPr algn="l">
+              <a:buNone/>
               <a:defRPr sz="2925" b="1">
                 <a:solidFill>
                   <a:srgbClr val="051C2A"/>
@@ -3758,6 +3785,7 @@
           <a:lstStyle xmlns:a="http://schemas.openxmlformats.org/drawingml/2006/main"/>
           <a:p xmlns:a="http://schemas.openxmlformats.org/drawingml/2006/main">
             <a:pPr algn="l">
+              <a:buNone/>
               <a:defRPr sz="975" b="0">
                 <a:solidFill>
                   <a:srgbClr val="9E9FA2"/>
@@ -3770,7 +3798,7 @@
                   <a:srgbClr val="9E9FA2"/>
                 </a:solidFill>
               </a:rPr>
-              <a:t>FinAI Academy — Arnaud Demes</a:t>
+              <a:t>First Finance - Arnaud Demes</a:t>
             </a:r>
           </a:p>
         </p:txBody>
@@ -3808,6 +3836,7 @@
           <a:lstStyle xmlns:a="http://schemas.openxmlformats.org/drawingml/2006/main"/>
           <a:p xmlns:a="http://schemas.openxmlformats.org/drawingml/2006/main">
             <a:pPr algn="r">
+              <a:buNone/>
               <a:defRPr sz="900" b="1">
                 <a:solidFill>
                   <a:srgbClr val="9E9FA2"/>
@@ -3858,6 +3887,7 @@
           <a:lstStyle xmlns:a="http://schemas.openxmlformats.org/drawingml/2006/main"/>
           <a:p xmlns:a="http://schemas.openxmlformats.org/drawingml/2006/main">
             <a:pPr algn="r">
+              <a:buNone/>
               <a:defRPr sz="900" b="1">
                 <a:solidFill>
                   <a:srgbClr val="9E9FA2"/>
@@ -3943,6 +3973,7 @@
           <a:lstStyle xmlns:a="http://schemas.openxmlformats.org/drawingml/2006/main"/>
           <a:p xmlns:a="http://schemas.openxmlformats.org/drawingml/2006/main">
             <a:pPr algn="l">
+              <a:buNone/>
               <a:defRPr sz="1275" b="1">
                 <a:solidFill>
                   <a:srgbClr val="00A2EB"/>
@@ -3993,6 +4024,7 @@
           <a:lstStyle xmlns:a="http://schemas.openxmlformats.org/drawingml/2006/main"/>
           <a:p xmlns:a="http://schemas.openxmlformats.org/drawingml/2006/main">
             <a:pPr algn="l">
+              <a:buNone/>
               <a:defRPr sz="2250" b="1">
                 <a:solidFill>
                   <a:srgbClr val="FFFFFF"/>
@@ -4043,6 +4075,7 @@
           <a:lstStyle xmlns:a="http://schemas.openxmlformats.org/drawingml/2006/main"/>
           <a:p xmlns:a="http://schemas.openxmlformats.org/drawingml/2006/main">
             <a:pPr algn="l">
+              <a:buNone/>
               <a:defRPr sz="1350" b="0">
                 <a:solidFill>
                   <a:srgbClr val="F5F5F5"/>
@@ -4060,6 +4093,7 @@
           </a:p>
           <a:p xmlns:a="http://schemas.openxmlformats.org/drawingml/2006/main">
             <a:pPr algn="l">
+              <a:buNone/>
               <a:defRPr sz="1350" b="0">
                 <a:solidFill>
                   <a:srgbClr val="F5F5F5"/>
@@ -4145,6 +4179,7 @@
           <a:lstStyle xmlns:a="http://schemas.openxmlformats.org/drawingml/2006/main"/>
           <a:p xmlns:a="http://schemas.openxmlformats.org/drawingml/2006/main">
             <a:pPr algn="l">
+              <a:buNone/>
               <a:defRPr sz="1275" b="1">
                 <a:solidFill>
                   <a:srgbClr val="1F40CB"/>
@@ -4195,6 +4230,7 @@
           <a:lstStyle xmlns:a="http://schemas.openxmlformats.org/drawingml/2006/main"/>
           <a:p xmlns:a="http://schemas.openxmlformats.org/drawingml/2006/main">
             <a:pPr algn="l">
+              <a:buNone/>
               <a:defRPr sz="2250" b="1">
                 <a:solidFill>
                   <a:srgbClr val="051C2A"/>
@@ -4245,6 +4281,7 @@
           <a:lstStyle xmlns:a="http://schemas.openxmlformats.org/drawingml/2006/main"/>
           <a:p xmlns:a="http://schemas.openxmlformats.org/drawingml/2006/main">
             <a:pPr algn="l">
+              <a:buNone/>
               <a:defRPr sz="1350" b="0">
                 <a:solidFill>
                   <a:srgbClr val="373738"/>
@@ -4262,6 +4299,7 @@
           </a:p>
           <a:p xmlns:a="http://schemas.openxmlformats.org/drawingml/2006/main">
             <a:pPr algn="l">
+              <a:buNone/>
               <a:defRPr sz="1350" b="0">
                 <a:solidFill>
                   <a:srgbClr val="373738"/>
@@ -4312,6 +4350,7 @@
           <a:lstStyle xmlns:a="http://schemas.openxmlformats.org/drawingml/2006/main"/>
           <a:p xmlns:a="http://schemas.openxmlformats.org/drawingml/2006/main">
             <a:pPr algn="ctr">
+              <a:buNone/>
               <a:defRPr sz="1275" b="1">
                 <a:solidFill>
                   <a:srgbClr val="F07D00"/>
@@ -4362,6 +4401,7 @@
           <a:lstStyle xmlns:a="http://schemas.openxmlformats.org/drawingml/2006/main"/>
           <a:p xmlns:a="http://schemas.openxmlformats.org/drawingml/2006/main">
             <a:pPr algn="ctr">
+              <a:buNone/>
               <a:defRPr sz="2025" b="0">
                 <a:solidFill>
                   <a:srgbClr val="051C2A"/>
@@ -4374,7 +4414,7 @@
                   <a:srgbClr val="051C2A"/>
                 </a:solidFill>
               </a:rPr>
-              <a:t>Change configuration — never the lesson code.</a:t>
+              <a:t>Provider selection changes through configuration only.</a:t>
             </a:r>
           </a:p>
         </p:txBody>
@@ -4441,6 +4481,7 @@
           <a:lstStyle xmlns:a="http://schemas.openxmlformats.org/drawingml/2006/main"/>
           <a:p xmlns:a="http://schemas.openxmlformats.org/drawingml/2006/main">
             <a:pPr algn="l">
+              <a:buNone/>
               <a:defRPr sz="1050" b="1">
                 <a:solidFill>
                   <a:srgbClr val="1F40CB"/>
@@ -4491,6 +4532,7 @@
           <a:lstStyle xmlns:a="http://schemas.openxmlformats.org/drawingml/2006/main"/>
           <a:p xmlns:a="http://schemas.openxmlformats.org/drawingml/2006/main">
             <a:pPr algn="l">
+              <a:buNone/>
               <a:defRPr sz="2925" b="1">
                 <a:solidFill>
                   <a:srgbClr val="051C2A"/>
@@ -4503,7 +4545,7 @@
                   <a:srgbClr val="051C2A"/>
                 </a:solidFill>
               </a:rPr>
-              <a:t>Success means a working, inspectable and defensible copilot</a:t>
+              <a:t>Expected deliverables and validation criteria</a:t>
             </a:r>
           </a:p>
         </p:txBody>
@@ -4603,6 +4645,7 @@
           <a:lstStyle xmlns:a="http://schemas.openxmlformats.org/drawingml/2006/main"/>
           <a:p xmlns:a="http://schemas.openxmlformats.org/drawingml/2006/main">
             <a:pPr algn="l">
+              <a:buNone/>
               <a:defRPr sz="975" b="0">
                 <a:solidFill>
                   <a:srgbClr val="9E9FA2"/>
@@ -4615,7 +4658,7 @@
                   <a:srgbClr val="9E9FA2"/>
                 </a:solidFill>
               </a:rPr>
-              <a:t>FinAI Academy — Arnaud Demes</a:t>
+              <a:t>First Finance - Arnaud Demes</a:t>
             </a:r>
           </a:p>
         </p:txBody>
@@ -4653,6 +4696,7 @@
           <a:lstStyle xmlns:a="http://schemas.openxmlformats.org/drawingml/2006/main"/>
           <a:p xmlns:a="http://schemas.openxmlformats.org/drawingml/2006/main">
             <a:pPr algn="r">
+              <a:buNone/>
               <a:defRPr sz="900" b="1">
                 <a:solidFill>
                   <a:srgbClr val="9E9FA2"/>
@@ -4665,7 +4709,7 @@
                   <a:srgbClr val="9E9FA2"/>
                 </a:solidFill>
               </a:rPr>
-              <a:t>SUCCESS</a:t>
+              <a:t>VALIDATION</a:t>
             </a:r>
           </a:p>
         </p:txBody>
@@ -4703,6 +4747,7 @@
           <a:lstStyle xmlns:a="http://schemas.openxmlformats.org/drawingml/2006/main"/>
           <a:p xmlns:a="http://schemas.openxmlformats.org/drawingml/2006/main">
             <a:pPr algn="r">
+              <a:buNone/>
               <a:defRPr sz="900" b="1">
                 <a:solidFill>
                   <a:srgbClr val="9E9FA2"/>
@@ -4784,6 +4829,7 @@
           <a:lstStyle xmlns:a="http://schemas.openxmlformats.org/drawingml/2006/main"/>
           <a:p xmlns:a="http://schemas.openxmlformats.org/drawingml/2006/main">
             <a:pPr algn="l">
+              <a:buNone/>
               <a:defRPr sz="1125" b="1">
                 <a:solidFill>
                   <a:srgbClr val="1F40CB"/>
@@ -4834,6 +4880,7 @@
           <a:lstStyle xmlns:a="http://schemas.openxmlformats.org/drawingml/2006/main"/>
           <a:p xmlns:a="http://schemas.openxmlformats.org/drawingml/2006/main">
             <a:pPr algn="l">
+              <a:buNone/>
               <a:defRPr sz="1650" b="1">
                 <a:solidFill>
                   <a:srgbClr val="051C2A"/>
@@ -4915,6 +4962,7 @@
           <a:lstStyle xmlns:a="http://schemas.openxmlformats.org/drawingml/2006/main"/>
           <a:p xmlns:a="http://schemas.openxmlformats.org/drawingml/2006/main">
             <a:pPr algn="l">
+              <a:buNone/>
               <a:defRPr sz="1125" b="1">
                 <a:solidFill>
                   <a:srgbClr val="1F40CB"/>
@@ -4965,6 +5013,7 @@
           <a:lstStyle xmlns:a="http://schemas.openxmlformats.org/drawingml/2006/main"/>
           <a:p xmlns:a="http://schemas.openxmlformats.org/drawingml/2006/main">
             <a:pPr algn="l">
+              <a:buNone/>
               <a:defRPr sz="1650" b="1">
                 <a:solidFill>
                   <a:srgbClr val="051C2A"/>
@@ -5046,6 +5095,7 @@
           <a:lstStyle xmlns:a="http://schemas.openxmlformats.org/drawingml/2006/main"/>
           <a:p xmlns:a="http://schemas.openxmlformats.org/drawingml/2006/main">
             <a:pPr algn="l">
+              <a:buNone/>
               <a:defRPr sz="1125" b="1">
                 <a:solidFill>
                   <a:srgbClr val="F07D00"/>
@@ -5096,6 +5146,7 @@
           <a:lstStyle xmlns:a="http://schemas.openxmlformats.org/drawingml/2006/main"/>
           <a:p xmlns:a="http://schemas.openxmlformats.org/drawingml/2006/main">
             <a:pPr algn="l">
+              <a:buNone/>
               <a:defRPr sz="1650" b="1">
                 <a:solidFill>
                   <a:srgbClr val="051C2A"/>
@@ -5177,6 +5228,7 @@
           <a:lstStyle xmlns:a="http://schemas.openxmlformats.org/drawingml/2006/main"/>
           <a:p xmlns:a="http://schemas.openxmlformats.org/drawingml/2006/main">
             <a:pPr algn="l">
+              <a:buNone/>
               <a:defRPr sz="1125" b="1">
                 <a:solidFill>
                   <a:srgbClr val="1F40CB"/>
@@ -5227,6 +5279,7 @@
           <a:lstStyle xmlns:a="http://schemas.openxmlformats.org/drawingml/2006/main"/>
           <a:p xmlns:a="http://schemas.openxmlformats.org/drawingml/2006/main">
             <a:pPr algn="l">
+              <a:buNone/>
               <a:defRPr sz="1650" b="1">
                 <a:solidFill>
                   <a:srgbClr val="051C2A"/>
@@ -5277,6 +5330,7 @@
           <a:lstStyle xmlns:a="http://schemas.openxmlformats.org/drawingml/2006/main"/>
           <a:p xmlns:a="http://schemas.openxmlformats.org/drawingml/2006/main">
             <a:pPr algn="r">
+              <a:buNone/>
               <a:defRPr sz="2175" b="1">
                 <a:solidFill>
                   <a:srgbClr val="051C2A"/>
@@ -5289,7 +5343,7 @@
                   <a:srgbClr val="051C2A"/>
                 </a:solidFill>
               </a:rPr>
-              <a:t>Now build the first response.</a:t>
+              <a:t>Next: Model Gateway</a:t>
             </a:r>
           </a:p>
         </p:txBody>
@@ -5356,6 +5410,7 @@
           <a:lstStyle xmlns:a="http://schemas.openxmlformats.org/drawingml/2006/main"/>
           <a:p xmlns:a="http://schemas.openxmlformats.org/drawingml/2006/main">
             <a:pPr algn="l">
+              <a:buNone/>
               <a:defRPr sz="1050" b="1">
                 <a:solidFill>
                   <a:srgbClr val="1F40CB"/>
@@ -5406,6 +5461,7 @@
           <a:lstStyle xmlns:a="http://schemas.openxmlformats.org/drawingml/2006/main"/>
           <a:p xmlns:a="http://schemas.openxmlformats.org/drawingml/2006/main">
             <a:pPr algn="l">
+              <a:buNone/>
               <a:defRPr sz="2925" b="1">
                 <a:solidFill>
                   <a:srgbClr val="051C2A"/>
@@ -5418,7 +5474,7 @@
                   <a:srgbClr val="051C2A"/>
                 </a:solidFill>
               </a:rPr>
-              <a:t>In two days, one analyst copilot becomes a complete AI system</a:t>
+              <a:t>Course objective: build a financial analyst copilot across the full stack</a:t>
             </a:r>
           </a:p>
         </p:txBody>
@@ -5518,6 +5574,7 @@
           <a:lstStyle xmlns:a="http://schemas.openxmlformats.org/drawingml/2006/main"/>
           <a:p xmlns:a="http://schemas.openxmlformats.org/drawingml/2006/main">
             <a:pPr algn="l">
+              <a:buNone/>
               <a:defRPr sz="975" b="0">
                 <a:solidFill>
                   <a:srgbClr val="9E9FA2"/>
@@ -5530,7 +5587,7 @@
                   <a:srgbClr val="9E9FA2"/>
                 </a:solidFill>
               </a:rPr>
-              <a:t>FinAI Academy — Arnaud Demes</a:t>
+              <a:t>First Finance - Arnaud Demes</a:t>
             </a:r>
           </a:p>
         </p:txBody>
@@ -5568,6 +5625,7 @@
           <a:lstStyle xmlns:a="http://schemas.openxmlformats.org/drawingml/2006/main"/>
           <a:p xmlns:a="http://schemas.openxmlformats.org/drawingml/2006/main">
             <a:pPr algn="r">
+              <a:buNone/>
               <a:defRPr sz="900" b="1">
                 <a:solidFill>
                   <a:srgbClr val="9E9FA2"/>
@@ -5580,7 +5638,7 @@
                   <a:srgbClr val="9E9FA2"/>
                 </a:solidFill>
               </a:rPr>
-              <a:t>PROMISE</a:t>
+              <a:t>OBJECTIVE</a:t>
             </a:r>
           </a:p>
         </p:txBody>
@@ -5618,6 +5676,7 @@
           <a:lstStyle xmlns:a="http://schemas.openxmlformats.org/drawingml/2006/main"/>
           <a:p xmlns:a="http://schemas.openxmlformats.org/drawingml/2006/main">
             <a:pPr algn="r">
+              <a:buNone/>
               <a:defRPr sz="900" b="1">
                 <a:solidFill>
                   <a:srgbClr val="9E9FA2"/>
@@ -5668,6 +5727,7 @@
           <a:lstStyle xmlns:a="http://schemas.openxmlformats.org/drawingml/2006/main"/>
           <a:p xmlns:a="http://schemas.openxmlformats.org/drawingml/2006/main">
             <a:pPr algn="l">
+              <a:buNone/>
               <a:defRPr sz="1050" b="1">
                 <a:solidFill>
                   <a:srgbClr val="00A2EB"/>
@@ -5749,6 +5809,7 @@
           <a:lstStyle xmlns:a="http://schemas.openxmlformats.org/drawingml/2006/main"/>
           <a:p xmlns:a="http://schemas.openxmlformats.org/drawingml/2006/main">
             <a:pPr algn="l">
+              <a:buNone/>
               <a:defRPr sz="1350" b="1">
                 <a:solidFill>
                   <a:srgbClr val="051C2A"/>
@@ -5799,6 +5860,7 @@
           <a:lstStyle xmlns:a="http://schemas.openxmlformats.org/drawingml/2006/main"/>
           <a:p xmlns:a="http://schemas.openxmlformats.org/drawingml/2006/main">
             <a:pPr algn="l">
+              <a:buNone/>
               <a:defRPr sz="1350" b="0">
                 <a:solidFill>
                   <a:srgbClr val="373738"/>
@@ -5849,6 +5911,7 @@
           <a:lstStyle xmlns:a="http://schemas.openxmlformats.org/drawingml/2006/main"/>
           <a:p xmlns:a="http://schemas.openxmlformats.org/drawingml/2006/main">
             <a:pPr algn="l">
+              <a:buNone/>
               <a:defRPr sz="1050" b="1">
                 <a:solidFill>
                   <a:srgbClr val="00A2EB"/>
@@ -5930,6 +5993,7 @@
           <a:lstStyle xmlns:a="http://schemas.openxmlformats.org/drawingml/2006/main"/>
           <a:p xmlns:a="http://schemas.openxmlformats.org/drawingml/2006/main">
             <a:pPr algn="l">
+              <a:buNone/>
               <a:defRPr sz="1350" b="1">
                 <a:solidFill>
                   <a:srgbClr val="051C2A"/>
@@ -5980,6 +6044,7 @@
           <a:lstStyle xmlns:a="http://schemas.openxmlformats.org/drawingml/2006/main"/>
           <a:p xmlns:a="http://schemas.openxmlformats.org/drawingml/2006/main">
             <a:pPr algn="l">
+              <a:buNone/>
               <a:defRPr sz="1350" b="0">
                 <a:solidFill>
                   <a:srgbClr val="373738"/>
@@ -6030,6 +6095,7 @@
           <a:lstStyle xmlns:a="http://schemas.openxmlformats.org/drawingml/2006/main"/>
           <a:p xmlns:a="http://schemas.openxmlformats.org/drawingml/2006/main">
             <a:pPr algn="l">
+              <a:buNone/>
               <a:defRPr sz="1050" b="1">
                 <a:solidFill>
                   <a:srgbClr val="00A2EB"/>
@@ -6111,6 +6177,7 @@
           <a:lstStyle xmlns:a="http://schemas.openxmlformats.org/drawingml/2006/main"/>
           <a:p xmlns:a="http://schemas.openxmlformats.org/drawingml/2006/main">
             <a:pPr algn="l">
+              <a:buNone/>
               <a:defRPr sz="1350" b="1">
                 <a:solidFill>
                   <a:srgbClr val="051C2A"/>
@@ -6161,6 +6228,7 @@
           <a:lstStyle xmlns:a="http://schemas.openxmlformats.org/drawingml/2006/main"/>
           <a:p xmlns:a="http://schemas.openxmlformats.org/drawingml/2006/main">
             <a:pPr algn="l">
+              <a:buNone/>
               <a:defRPr sz="1350" b="0">
                 <a:solidFill>
                   <a:srgbClr val="373738"/>
@@ -6211,6 +6279,7 @@
           <a:lstStyle xmlns:a="http://schemas.openxmlformats.org/drawingml/2006/main"/>
           <a:p xmlns:a="http://schemas.openxmlformats.org/drawingml/2006/main">
             <a:pPr algn="l">
+              <a:buNone/>
               <a:defRPr sz="1050" b="1">
                 <a:solidFill>
                   <a:srgbClr val="00A2EB"/>
@@ -6292,6 +6361,7 @@
           <a:lstStyle xmlns:a="http://schemas.openxmlformats.org/drawingml/2006/main"/>
           <a:p xmlns:a="http://schemas.openxmlformats.org/drawingml/2006/main">
             <a:pPr algn="l">
+              <a:buNone/>
               <a:defRPr sz="1350" b="1">
                 <a:solidFill>
                   <a:srgbClr val="051C2A"/>
@@ -6342,6 +6412,7 @@
           <a:lstStyle xmlns:a="http://schemas.openxmlformats.org/drawingml/2006/main"/>
           <a:p xmlns:a="http://schemas.openxmlformats.org/drawingml/2006/main">
             <a:pPr algn="l">
+              <a:buNone/>
               <a:defRPr sz="1350" b="0">
                 <a:solidFill>
                   <a:srgbClr val="373738"/>
@@ -6392,6 +6463,7 @@
           <a:lstStyle xmlns:a="http://schemas.openxmlformats.org/drawingml/2006/main"/>
           <a:p xmlns:a="http://schemas.openxmlformats.org/drawingml/2006/main">
             <a:pPr algn="l">
+              <a:buNone/>
               <a:defRPr sz="1050" b="1">
                 <a:solidFill>
                   <a:srgbClr val="F07D00"/>
@@ -6473,6 +6545,7 @@
           <a:lstStyle xmlns:a="http://schemas.openxmlformats.org/drawingml/2006/main"/>
           <a:p xmlns:a="http://schemas.openxmlformats.org/drawingml/2006/main">
             <a:pPr algn="l">
+              <a:buNone/>
               <a:defRPr sz="1350" b="1">
                 <a:solidFill>
                   <a:srgbClr val="051C2A"/>
@@ -6523,6 +6596,7 @@
           <a:lstStyle xmlns:a="http://schemas.openxmlformats.org/drawingml/2006/main"/>
           <a:p xmlns:a="http://schemas.openxmlformats.org/drawingml/2006/main">
             <a:pPr algn="l">
+              <a:buNone/>
               <a:defRPr sz="1350" b="0">
                 <a:solidFill>
                   <a:srgbClr val="373738"/>
@@ -6573,6 +6647,7 @@
           <a:lstStyle xmlns:a="http://schemas.openxmlformats.org/drawingml/2006/main"/>
           <a:p xmlns:a="http://schemas.openxmlformats.org/drawingml/2006/main">
             <a:pPr algn="l">
+              <a:buNone/>
               <a:defRPr sz="2175" b="0">
                 <a:solidFill>
                   <a:srgbClr val="051C2A"/>
@@ -6585,7 +6660,7 @@
                   <a:srgbClr val="051C2A"/>
                 </a:solidFill>
               </a:rPr>
-              <a:t>The objective is not to know the vocabulary. It is to leave with an inspectable application that works.</a:t>
+              <a:t>At the end of the course, the application runs end to end and exposes its sources, calculations, tool calls and evaluations.</a:t>
             </a:r>
           </a:p>
         </p:txBody>
@@ -6652,6 +6727,7 @@
           <a:lstStyle xmlns:a="http://schemas.openxmlformats.org/drawingml/2006/main"/>
           <a:p xmlns:a="http://schemas.openxmlformats.org/drawingml/2006/main">
             <a:pPr algn="l">
+              <a:buNone/>
               <a:defRPr sz="1050" b="1">
                 <a:solidFill>
                   <a:srgbClr val="1F40CB"/>
@@ -6702,6 +6778,7 @@
           <a:lstStyle xmlns:a="http://schemas.openxmlformats.org/drawingml/2006/main"/>
           <a:p xmlns:a="http://schemas.openxmlformats.org/drawingml/2006/main">
             <a:pPr algn="l">
+              <a:buNone/>
               <a:defRPr sz="2925" b="1">
                 <a:solidFill>
                   <a:srgbClr val="051C2A"/>
@@ -6714,7 +6791,7 @@
                   <a:srgbClr val="051C2A"/>
                 </a:solidFill>
               </a:rPr>
-              <a:t>The product comes first</a:t>
+              <a:t>Capstone project: Financial Analyst Copilot</a:t>
             </a:r>
           </a:p>
         </p:txBody>
@@ -6814,6 +6891,7 @@
           <a:lstStyle xmlns:a="http://schemas.openxmlformats.org/drawingml/2006/main"/>
           <a:p xmlns:a="http://schemas.openxmlformats.org/drawingml/2006/main">
             <a:pPr algn="l">
+              <a:buNone/>
               <a:defRPr sz="975" b="0">
                 <a:solidFill>
                   <a:srgbClr val="9E9FA2"/>
@@ -6826,7 +6904,7 @@
                   <a:srgbClr val="9E9FA2"/>
                 </a:solidFill>
               </a:rPr>
-              <a:t>FinAI Academy — Arnaud Demes</a:t>
+              <a:t>First Finance - Arnaud Demes</a:t>
             </a:r>
           </a:p>
         </p:txBody>
@@ -6864,6 +6942,7 @@
           <a:lstStyle xmlns:a="http://schemas.openxmlformats.org/drawingml/2006/main"/>
           <a:p xmlns:a="http://schemas.openxmlformats.org/drawingml/2006/main">
             <a:pPr algn="r">
+              <a:buNone/>
               <a:defRPr sz="900" b="1">
                 <a:solidFill>
                   <a:srgbClr val="9E9FA2"/>
@@ -6876,7 +6955,7 @@
                   <a:srgbClr val="9E9FA2"/>
                 </a:solidFill>
               </a:rPr>
-              <a:t>PRODUCT</a:t>
+              <a:t>CAPSTONE</a:t>
             </a:r>
           </a:p>
         </p:txBody>
@@ -6914,6 +6993,7 @@
           <a:lstStyle xmlns:a="http://schemas.openxmlformats.org/drawingml/2006/main"/>
           <a:p xmlns:a="http://schemas.openxmlformats.org/drawingml/2006/main">
             <a:pPr algn="r">
+              <a:buNone/>
               <a:defRPr sz="900" b="1">
                 <a:solidFill>
                   <a:srgbClr val="9E9FA2"/>
@@ -6964,6 +7044,7 @@
           <a:lstStyle xmlns:a="http://schemas.openxmlformats.org/drawingml/2006/main"/>
           <a:p xmlns:a="http://schemas.openxmlformats.org/drawingml/2006/main">
             <a:pPr algn="l">
+              <a:buNone/>
               <a:defRPr sz="2100" b="0">
                 <a:solidFill>
                   <a:srgbClr val="051C2A"/>
@@ -7045,6 +7126,7 @@
           <a:lstStyle xmlns:a="http://schemas.openxmlformats.org/drawingml/2006/main"/>
           <a:p xmlns:a="http://schemas.openxmlformats.org/drawingml/2006/main">
             <a:pPr algn="l">
+              <a:buNone/>
               <a:defRPr sz="1575" b="1">
                 <a:solidFill>
                   <a:srgbClr val="373738"/>
@@ -7095,6 +7177,7 @@
           <a:lstStyle xmlns:a="http://schemas.openxmlformats.org/drawingml/2006/main"/>
           <a:p xmlns:a="http://schemas.openxmlformats.org/drawingml/2006/main">
             <a:pPr algn="l">
+              <a:buNone/>
               <a:defRPr sz="1050" b="1">
                 <a:solidFill>
                   <a:srgbClr val="00A2EB"/>
@@ -7145,6 +7228,7 @@
           <a:lstStyle xmlns:a="http://schemas.openxmlformats.org/drawingml/2006/main"/>
           <a:p xmlns:a="http://schemas.openxmlformats.org/drawingml/2006/main">
             <a:pPr algn="l">
+              <a:buNone/>
               <a:defRPr sz="1800" b="1">
                 <a:solidFill>
                   <a:srgbClr val="051C2A"/>
@@ -7226,6 +7310,7 @@
           <a:lstStyle xmlns:a="http://schemas.openxmlformats.org/drawingml/2006/main"/>
           <a:p xmlns:a="http://schemas.openxmlformats.org/drawingml/2006/main">
             <a:pPr algn="l">
+              <a:buNone/>
               <a:defRPr sz="1050" b="1">
                 <a:solidFill>
                   <a:srgbClr val="00A2EB"/>
@@ -7276,6 +7361,7 @@
           <a:lstStyle xmlns:a="http://schemas.openxmlformats.org/drawingml/2006/main"/>
           <a:p xmlns:a="http://schemas.openxmlformats.org/drawingml/2006/main">
             <a:pPr algn="l">
+              <a:buNone/>
               <a:defRPr sz="1800" b="1">
                 <a:solidFill>
                   <a:srgbClr val="051C2A"/>
@@ -7357,6 +7443,7 @@
           <a:lstStyle xmlns:a="http://schemas.openxmlformats.org/drawingml/2006/main"/>
           <a:p xmlns:a="http://schemas.openxmlformats.org/drawingml/2006/main">
             <a:pPr algn="l">
+              <a:buNone/>
               <a:defRPr sz="1050" b="1">
                 <a:solidFill>
                   <a:srgbClr val="00A2EB"/>
@@ -7407,6 +7494,7 @@
           <a:lstStyle xmlns:a="http://schemas.openxmlformats.org/drawingml/2006/main"/>
           <a:p xmlns:a="http://schemas.openxmlformats.org/drawingml/2006/main">
             <a:pPr algn="l">
+              <a:buNone/>
               <a:defRPr sz="1800" b="1">
                 <a:solidFill>
                   <a:srgbClr val="051C2A"/>
@@ -7488,6 +7576,7 @@
           <a:lstStyle xmlns:a="http://schemas.openxmlformats.org/drawingml/2006/main"/>
           <a:p xmlns:a="http://schemas.openxmlformats.org/drawingml/2006/main">
             <a:pPr algn="l">
+              <a:buNone/>
               <a:defRPr sz="1050" b="1">
                 <a:solidFill>
                   <a:srgbClr val="F07D00"/>
@@ -7538,6 +7627,7 @@
           <a:lstStyle xmlns:a="http://schemas.openxmlformats.org/drawingml/2006/main"/>
           <a:p xmlns:a="http://schemas.openxmlformats.org/drawingml/2006/main">
             <a:pPr algn="l">
+              <a:buNone/>
               <a:defRPr sz="1800" b="1">
                 <a:solidFill>
                   <a:srgbClr val="051C2A"/>
@@ -7648,6 +7738,7 @@
           <a:lstStyle xmlns:a="http://schemas.openxmlformats.org/drawingml/2006/main"/>
           <a:p xmlns:a="http://schemas.openxmlformats.org/drawingml/2006/main">
             <a:pPr algn="l">
+              <a:buNone/>
               <a:defRPr sz="1050" b="1">
                 <a:solidFill>
                   <a:srgbClr val="1F40CB"/>
@@ -7698,6 +7789,7 @@
           <a:lstStyle xmlns:a="http://schemas.openxmlformats.org/drawingml/2006/main"/>
           <a:p xmlns:a="http://schemas.openxmlformats.org/drawingml/2006/main">
             <a:pPr algn="l">
+              <a:buNone/>
               <a:defRPr sz="2925" b="1">
                 <a:solidFill>
                   <a:srgbClr val="051C2A"/>
@@ -7710,7 +7802,7 @@
                   <a:srgbClr val="051C2A"/>
                 </a:solidFill>
               </a:rPr>
-              <a:t>Each failure creates the need for the next engineering layer</a:t>
+              <a:t>Technical progression of the application</a:t>
             </a:r>
           </a:p>
         </p:txBody>
@@ -7810,6 +7902,7 @@
           <a:lstStyle xmlns:a="http://schemas.openxmlformats.org/drawingml/2006/main"/>
           <a:p xmlns:a="http://schemas.openxmlformats.org/drawingml/2006/main">
             <a:pPr algn="l">
+              <a:buNone/>
               <a:defRPr sz="975" b="0">
                 <a:solidFill>
                   <a:srgbClr val="9E9FA2"/>
@@ -7822,7 +7915,7 @@
                   <a:srgbClr val="9E9FA2"/>
                 </a:solidFill>
               </a:rPr>
-              <a:t>FinAI Academy — Arnaud Demes</a:t>
+              <a:t>First Finance - Arnaud Demes</a:t>
             </a:r>
           </a:p>
         </p:txBody>
@@ -7860,6 +7953,7 @@
           <a:lstStyle xmlns:a="http://schemas.openxmlformats.org/drawingml/2006/main"/>
           <a:p xmlns:a="http://schemas.openxmlformats.org/drawingml/2006/main">
             <a:pPr algn="r">
+              <a:buNone/>
               <a:defRPr sz="900" b="1">
                 <a:solidFill>
                   <a:srgbClr val="9E9FA2"/>
@@ -7910,6 +8004,7 @@
           <a:lstStyle xmlns:a="http://schemas.openxmlformats.org/drawingml/2006/main"/>
           <a:p xmlns:a="http://schemas.openxmlformats.org/drawingml/2006/main">
             <a:pPr algn="r">
+              <a:buNone/>
               <a:defRPr sz="900" b="1">
                 <a:solidFill>
                   <a:srgbClr val="9E9FA2"/>
@@ -7995,6 +8090,7 @@
           <a:lstStyle xmlns:a="http://schemas.openxmlformats.org/drawingml/2006/main"/>
           <a:p xmlns:a="http://schemas.openxmlformats.org/drawingml/2006/main">
             <a:pPr algn="l">
+              <a:buNone/>
               <a:defRPr sz="1650" b="1">
                 <a:solidFill>
                   <a:srgbClr val="051C2A"/>
@@ -8045,6 +8141,7 @@
           <a:lstStyle xmlns:a="http://schemas.openxmlformats.org/drawingml/2006/main"/>
           <a:p xmlns:a="http://schemas.openxmlformats.org/drawingml/2006/main">
             <a:pPr algn="l">
+              <a:buNone/>
               <a:defRPr sz="1200" b="0">
                 <a:solidFill>
                   <a:srgbClr val="373738"/>
@@ -8095,6 +8192,7 @@
           <a:lstStyle xmlns:a="http://schemas.openxmlformats.org/drawingml/2006/main"/>
           <a:p xmlns:a="http://schemas.openxmlformats.org/drawingml/2006/main">
             <a:pPr algn="ctr">
+              <a:buNone/>
               <a:defRPr sz="1800" b="1">
                 <a:solidFill>
                   <a:srgbClr val="9E9FA2"/>
@@ -8180,6 +8278,7 @@
           <a:lstStyle xmlns:a="http://schemas.openxmlformats.org/drawingml/2006/main"/>
           <a:p xmlns:a="http://schemas.openxmlformats.org/drawingml/2006/main">
             <a:pPr algn="l">
+              <a:buNone/>
               <a:defRPr sz="1650" b="1">
                 <a:solidFill>
                   <a:srgbClr val="051C2A"/>
@@ -8230,6 +8329,7 @@
           <a:lstStyle xmlns:a="http://schemas.openxmlformats.org/drawingml/2006/main"/>
           <a:p xmlns:a="http://schemas.openxmlformats.org/drawingml/2006/main">
             <a:pPr algn="l">
+              <a:buNone/>
               <a:defRPr sz="1200" b="0">
                 <a:solidFill>
                   <a:srgbClr val="373738"/>
@@ -8280,6 +8380,7 @@
           <a:lstStyle xmlns:a="http://schemas.openxmlformats.org/drawingml/2006/main"/>
           <a:p xmlns:a="http://schemas.openxmlformats.org/drawingml/2006/main">
             <a:pPr algn="ctr">
+              <a:buNone/>
               <a:defRPr sz="1800" b="1">
                 <a:solidFill>
                   <a:srgbClr val="9E9FA2"/>
@@ -8365,6 +8466,7 @@
           <a:lstStyle xmlns:a="http://schemas.openxmlformats.org/drawingml/2006/main"/>
           <a:p xmlns:a="http://schemas.openxmlformats.org/drawingml/2006/main">
             <a:pPr algn="l">
+              <a:buNone/>
               <a:defRPr sz="1650" b="1">
                 <a:solidFill>
                   <a:srgbClr val="051C2A"/>
@@ -8415,6 +8517,7 @@
           <a:lstStyle xmlns:a="http://schemas.openxmlformats.org/drawingml/2006/main"/>
           <a:p xmlns:a="http://schemas.openxmlformats.org/drawingml/2006/main">
             <a:pPr algn="l">
+              <a:buNone/>
               <a:defRPr sz="1200" b="0">
                 <a:solidFill>
                   <a:srgbClr val="373738"/>
@@ -8465,6 +8568,7 @@
           <a:lstStyle xmlns:a="http://schemas.openxmlformats.org/drawingml/2006/main"/>
           <a:p xmlns:a="http://schemas.openxmlformats.org/drawingml/2006/main">
             <a:pPr algn="ctr">
+              <a:buNone/>
               <a:defRPr sz="1800" b="1">
                 <a:solidFill>
                   <a:srgbClr val="9E9FA2"/>
@@ -8550,6 +8654,7 @@
           <a:lstStyle xmlns:a="http://schemas.openxmlformats.org/drawingml/2006/main"/>
           <a:p xmlns:a="http://schemas.openxmlformats.org/drawingml/2006/main">
             <a:pPr algn="l">
+              <a:buNone/>
               <a:defRPr sz="1650" b="1">
                 <a:solidFill>
                   <a:srgbClr val="051C2A"/>
@@ -8600,6 +8705,7 @@
           <a:lstStyle xmlns:a="http://schemas.openxmlformats.org/drawingml/2006/main"/>
           <a:p xmlns:a="http://schemas.openxmlformats.org/drawingml/2006/main">
             <a:pPr algn="l">
+              <a:buNone/>
               <a:defRPr sz="1200" b="0">
                 <a:solidFill>
                   <a:srgbClr val="373738"/>
@@ -8685,6 +8791,7 @@
           <a:lstStyle xmlns:a="http://schemas.openxmlformats.org/drawingml/2006/main"/>
           <a:p xmlns:a="http://schemas.openxmlformats.org/drawingml/2006/main">
             <a:pPr algn="l">
+              <a:buNone/>
               <a:defRPr sz="1650" b="1">
                 <a:solidFill>
                   <a:srgbClr val="051C2A"/>
@@ -8735,6 +8842,7 @@
           <a:lstStyle xmlns:a="http://schemas.openxmlformats.org/drawingml/2006/main"/>
           <a:p xmlns:a="http://schemas.openxmlformats.org/drawingml/2006/main">
             <a:pPr algn="l">
+              <a:buNone/>
               <a:defRPr sz="1200" b="0">
                 <a:solidFill>
                   <a:srgbClr val="373738"/>
@@ -8785,6 +8893,7 @@
           <a:lstStyle xmlns:a="http://schemas.openxmlformats.org/drawingml/2006/main"/>
           <a:p xmlns:a="http://schemas.openxmlformats.org/drawingml/2006/main">
             <a:pPr algn="ctr">
+              <a:buNone/>
               <a:defRPr sz="1800" b="1">
                 <a:solidFill>
                   <a:srgbClr val="9E9FA2"/>
@@ -8870,6 +8979,7 @@
           <a:lstStyle xmlns:a="http://schemas.openxmlformats.org/drawingml/2006/main"/>
           <a:p xmlns:a="http://schemas.openxmlformats.org/drawingml/2006/main">
             <a:pPr algn="l">
+              <a:buNone/>
               <a:defRPr sz="1650" b="1">
                 <a:solidFill>
                   <a:srgbClr val="051C2A"/>
@@ -8920,6 +9030,7 @@
           <a:lstStyle xmlns:a="http://schemas.openxmlformats.org/drawingml/2006/main"/>
           <a:p xmlns:a="http://schemas.openxmlformats.org/drawingml/2006/main">
             <a:pPr algn="l">
+              <a:buNone/>
               <a:defRPr sz="1200" b="0">
                 <a:solidFill>
                   <a:srgbClr val="373738"/>
@@ -8970,6 +9081,7 @@
           <a:lstStyle xmlns:a="http://schemas.openxmlformats.org/drawingml/2006/main"/>
           <a:p xmlns:a="http://schemas.openxmlformats.org/drawingml/2006/main">
             <a:pPr algn="ctr">
+              <a:buNone/>
               <a:defRPr sz="1800" b="1">
                 <a:solidFill>
                   <a:srgbClr val="9E9FA2"/>
@@ -9055,6 +9167,7 @@
           <a:lstStyle xmlns:a="http://schemas.openxmlformats.org/drawingml/2006/main"/>
           <a:p xmlns:a="http://schemas.openxmlformats.org/drawingml/2006/main">
             <a:pPr algn="l">
+              <a:buNone/>
               <a:defRPr sz="1650" b="1">
                 <a:solidFill>
                   <a:srgbClr val="051C2A"/>
@@ -9105,6 +9218,7 @@
           <a:lstStyle xmlns:a="http://schemas.openxmlformats.org/drawingml/2006/main"/>
           <a:p xmlns:a="http://schemas.openxmlformats.org/drawingml/2006/main">
             <a:pPr algn="l">
+              <a:buNone/>
               <a:defRPr sz="1200" b="0">
                 <a:solidFill>
                   <a:srgbClr val="373738"/>
@@ -9155,6 +9269,7 @@
           <a:lstStyle xmlns:a="http://schemas.openxmlformats.org/drawingml/2006/main"/>
           <a:p xmlns:a="http://schemas.openxmlformats.org/drawingml/2006/main">
             <a:pPr algn="ctr">
+              <a:buNone/>
               <a:defRPr sz="1800" b="1">
                 <a:solidFill>
                   <a:srgbClr val="9E9FA2"/>
@@ -9240,6 +9355,7 @@
           <a:lstStyle xmlns:a="http://schemas.openxmlformats.org/drawingml/2006/main"/>
           <a:p xmlns:a="http://schemas.openxmlformats.org/drawingml/2006/main">
             <a:pPr algn="l">
+              <a:buNone/>
               <a:defRPr sz="1650" b="1">
                 <a:solidFill>
                   <a:srgbClr val="FFFFFF"/>
@@ -9290,6 +9406,7 @@
           <a:lstStyle xmlns:a="http://schemas.openxmlformats.org/drawingml/2006/main"/>
           <a:p xmlns:a="http://schemas.openxmlformats.org/drawingml/2006/main">
             <a:pPr algn="l">
+              <a:buNone/>
               <a:defRPr sz="1200" b="0">
                 <a:solidFill>
                   <a:srgbClr val="00A2EB"/>
@@ -9369,6 +9486,7 @@
           <a:lstStyle xmlns:a="http://schemas.openxmlformats.org/drawingml/2006/main"/>
           <a:p xmlns:a="http://schemas.openxmlformats.org/drawingml/2006/main">
             <a:pPr algn="l">
+              <a:buNone/>
               <a:defRPr sz="1050" b="1">
                 <a:solidFill>
                   <a:srgbClr val="1F40CB"/>
@@ -9419,6 +9537,7 @@
           <a:lstStyle xmlns:a="http://schemas.openxmlformats.org/drawingml/2006/main"/>
           <a:p xmlns:a="http://schemas.openxmlformats.org/drawingml/2006/main">
             <a:pPr algn="l">
+              <a:buNone/>
               <a:defRPr sz="2925" b="1">
                 <a:solidFill>
                   <a:srgbClr val="051C2A"/>
@@ -9531,6 +9650,7 @@
           <a:lstStyle xmlns:a="http://schemas.openxmlformats.org/drawingml/2006/main"/>
           <a:p xmlns:a="http://schemas.openxmlformats.org/drawingml/2006/main">
             <a:pPr algn="l">
+              <a:buNone/>
               <a:defRPr sz="975" b="0">
                 <a:solidFill>
                   <a:srgbClr val="9E9FA2"/>
@@ -9543,7 +9663,7 @@
                   <a:srgbClr val="9E9FA2"/>
                 </a:solidFill>
               </a:rPr>
-              <a:t>FinAI Academy — Arnaud Demes</a:t>
+              <a:t>First Finance - Arnaud Demes</a:t>
             </a:r>
           </a:p>
         </p:txBody>
@@ -9581,6 +9701,7 @@
           <a:lstStyle xmlns:a="http://schemas.openxmlformats.org/drawingml/2006/main"/>
           <a:p xmlns:a="http://schemas.openxmlformats.org/drawingml/2006/main">
             <a:pPr algn="r">
+              <a:buNone/>
               <a:defRPr sz="900" b="1">
                 <a:solidFill>
                   <a:srgbClr val="9E9FA2"/>
@@ -9631,6 +9752,7 @@
           <a:lstStyle xmlns:a="http://schemas.openxmlformats.org/drawingml/2006/main"/>
           <a:p xmlns:a="http://schemas.openxmlformats.org/drawingml/2006/main">
             <a:pPr algn="r">
+              <a:buNone/>
               <a:defRPr sz="900" b="1">
                 <a:solidFill>
                   <a:srgbClr val="9E9FA2"/>
@@ -9681,6 +9803,7 @@
           <a:lstStyle xmlns:a="http://schemas.openxmlformats.org/drawingml/2006/main"/>
           <a:p xmlns:a="http://schemas.openxmlformats.org/drawingml/2006/main">
             <a:pPr algn="l">
+              <a:buNone/>
               <a:defRPr sz="1125" b="1">
                 <a:solidFill>
                   <a:srgbClr val="00A2EB"/>
@@ -9731,6 +9854,7 @@
           <a:lstStyle xmlns:a="http://schemas.openxmlformats.org/drawingml/2006/main"/>
           <a:p xmlns:a="http://schemas.openxmlformats.org/drawingml/2006/main">
             <a:pPr algn="l">
+              <a:buNone/>
               <a:defRPr sz="1500" b="1">
                 <a:solidFill>
                   <a:srgbClr val="051C2A"/>
@@ -9781,6 +9905,7 @@
           <a:lstStyle xmlns:a="http://schemas.openxmlformats.org/drawingml/2006/main"/>
           <a:p xmlns:a="http://schemas.openxmlformats.org/drawingml/2006/main">
             <a:pPr algn="l">
+              <a:buNone/>
               <a:defRPr sz="1425" b="0">
                 <a:solidFill>
                   <a:srgbClr val="373738"/>
@@ -9862,6 +9987,7 @@
           <a:lstStyle xmlns:a="http://schemas.openxmlformats.org/drawingml/2006/main"/>
           <a:p xmlns:a="http://schemas.openxmlformats.org/drawingml/2006/main">
             <a:pPr algn="l">
+              <a:buNone/>
               <a:defRPr sz="1125" b="1">
                 <a:solidFill>
                   <a:srgbClr val="00A2EB"/>
@@ -9912,6 +10038,7 @@
           <a:lstStyle xmlns:a="http://schemas.openxmlformats.org/drawingml/2006/main"/>
           <a:p xmlns:a="http://schemas.openxmlformats.org/drawingml/2006/main">
             <a:pPr algn="l">
+              <a:buNone/>
               <a:defRPr sz="1500" b="1">
                 <a:solidFill>
                   <a:srgbClr val="051C2A"/>
@@ -9962,6 +10089,7 @@
           <a:lstStyle xmlns:a="http://schemas.openxmlformats.org/drawingml/2006/main"/>
           <a:p xmlns:a="http://schemas.openxmlformats.org/drawingml/2006/main">
             <a:pPr algn="l">
+              <a:buNone/>
               <a:defRPr sz="1425" b="0">
                 <a:solidFill>
                   <a:srgbClr val="373738"/>
@@ -10043,6 +10171,7 @@
           <a:lstStyle xmlns:a="http://schemas.openxmlformats.org/drawingml/2006/main"/>
           <a:p xmlns:a="http://schemas.openxmlformats.org/drawingml/2006/main">
             <a:pPr algn="l">
+              <a:buNone/>
               <a:defRPr sz="1125" b="1">
                 <a:solidFill>
                   <a:srgbClr val="F07D00"/>
@@ -10093,6 +10222,7 @@
           <a:lstStyle xmlns:a="http://schemas.openxmlformats.org/drawingml/2006/main"/>
           <a:p xmlns:a="http://schemas.openxmlformats.org/drawingml/2006/main">
             <a:pPr algn="l">
+              <a:buNone/>
               <a:defRPr sz="1500" b="1">
                 <a:solidFill>
                   <a:srgbClr val="051C2A"/>
@@ -10143,6 +10273,7 @@
           <a:lstStyle xmlns:a="http://schemas.openxmlformats.org/drawingml/2006/main"/>
           <a:p xmlns:a="http://schemas.openxmlformats.org/drawingml/2006/main">
             <a:pPr algn="l">
+              <a:buNone/>
               <a:defRPr sz="1425" b="0">
                 <a:solidFill>
                   <a:srgbClr val="373738"/>
@@ -10224,6 +10355,7 @@
           <a:lstStyle xmlns:a="http://schemas.openxmlformats.org/drawingml/2006/main"/>
           <a:p xmlns:a="http://schemas.openxmlformats.org/drawingml/2006/main">
             <a:pPr algn="l">
+              <a:buNone/>
               <a:defRPr sz="1125" b="1">
                 <a:solidFill>
                   <a:srgbClr val="00A2EB"/>
@@ -10274,6 +10406,7 @@
           <a:lstStyle xmlns:a="http://schemas.openxmlformats.org/drawingml/2006/main"/>
           <a:p xmlns:a="http://schemas.openxmlformats.org/drawingml/2006/main">
             <a:pPr algn="l">
+              <a:buNone/>
               <a:defRPr sz="1500" b="1">
                 <a:solidFill>
                   <a:srgbClr val="051C2A"/>
@@ -10324,6 +10457,7 @@
           <a:lstStyle xmlns:a="http://schemas.openxmlformats.org/drawingml/2006/main"/>
           <a:p xmlns:a="http://schemas.openxmlformats.org/drawingml/2006/main">
             <a:pPr algn="l">
+              <a:buNone/>
               <a:defRPr sz="1425" b="0">
                 <a:solidFill>
                   <a:srgbClr val="373738"/>
@@ -10405,6 +10539,7 @@
           <a:lstStyle xmlns:a="http://schemas.openxmlformats.org/drawingml/2006/main"/>
           <a:p xmlns:a="http://schemas.openxmlformats.org/drawingml/2006/main">
             <a:pPr algn="l">
+              <a:buNone/>
               <a:defRPr sz="1125" b="1">
                 <a:solidFill>
                   <a:srgbClr val="00A2EB"/>
@@ -10455,6 +10590,7 @@
           <a:lstStyle xmlns:a="http://schemas.openxmlformats.org/drawingml/2006/main"/>
           <a:p xmlns:a="http://schemas.openxmlformats.org/drawingml/2006/main">
             <a:pPr algn="l">
+              <a:buNone/>
               <a:defRPr sz="1500" b="1">
                 <a:solidFill>
                   <a:srgbClr val="051C2A"/>
@@ -10505,6 +10641,7 @@
           <a:lstStyle xmlns:a="http://schemas.openxmlformats.org/drawingml/2006/main"/>
           <a:p xmlns:a="http://schemas.openxmlformats.org/drawingml/2006/main">
             <a:pPr algn="l">
+              <a:buNone/>
               <a:defRPr sz="1425" b="0">
                 <a:solidFill>
                   <a:srgbClr val="373738"/>
@@ -10586,6 +10723,7 @@
           <a:lstStyle xmlns:a="http://schemas.openxmlformats.org/drawingml/2006/main"/>
           <a:p xmlns:a="http://schemas.openxmlformats.org/drawingml/2006/main">
             <a:pPr algn="l">
+              <a:buNone/>
               <a:defRPr sz="1125" b="1">
                 <a:solidFill>
                   <a:srgbClr val="00A2EB"/>
@@ -10636,6 +10774,7 @@
           <a:lstStyle xmlns:a="http://schemas.openxmlformats.org/drawingml/2006/main"/>
           <a:p xmlns:a="http://schemas.openxmlformats.org/drawingml/2006/main">
             <a:pPr algn="l">
+              <a:buNone/>
               <a:defRPr sz="1500" b="1">
                 <a:solidFill>
                   <a:srgbClr val="051C2A"/>
@@ -10686,6 +10825,7 @@
           <a:lstStyle xmlns:a="http://schemas.openxmlformats.org/drawingml/2006/main"/>
           <a:p xmlns:a="http://schemas.openxmlformats.org/drawingml/2006/main">
             <a:pPr algn="l">
+              <a:buNone/>
               <a:defRPr sz="1425" b="0">
                 <a:solidFill>
                   <a:srgbClr val="373738"/>
@@ -10796,6 +10936,7 @@
           <a:lstStyle xmlns:a="http://schemas.openxmlformats.org/drawingml/2006/main"/>
           <a:p xmlns:a="http://schemas.openxmlformats.org/drawingml/2006/main">
             <a:pPr algn="l">
+              <a:buNone/>
               <a:defRPr sz="1050" b="1">
                 <a:solidFill>
                   <a:srgbClr val="1F40CB"/>
@@ -10846,6 +10987,7 @@
           <a:lstStyle xmlns:a="http://schemas.openxmlformats.org/drawingml/2006/main"/>
           <a:p xmlns:a="http://schemas.openxmlformats.org/drawingml/2006/main">
             <a:pPr algn="l">
+              <a:buNone/>
               <a:defRPr sz="2925" b="1">
                 <a:solidFill>
                   <a:srgbClr val="051C2A"/>
@@ -10958,6 +11100,7 @@
           <a:lstStyle xmlns:a="http://schemas.openxmlformats.org/drawingml/2006/main"/>
           <a:p xmlns:a="http://schemas.openxmlformats.org/drawingml/2006/main">
             <a:pPr algn="l">
+              <a:buNone/>
               <a:defRPr sz="975" b="0">
                 <a:solidFill>
                   <a:srgbClr val="9E9FA2"/>
@@ -10970,7 +11113,7 @@
                   <a:srgbClr val="9E9FA2"/>
                 </a:solidFill>
               </a:rPr>
-              <a:t>FinAI Academy — Arnaud Demes</a:t>
+              <a:t>First Finance - Arnaud Demes</a:t>
             </a:r>
           </a:p>
         </p:txBody>
@@ -11008,6 +11151,7 @@
           <a:lstStyle xmlns:a="http://schemas.openxmlformats.org/drawingml/2006/main"/>
           <a:p xmlns:a="http://schemas.openxmlformats.org/drawingml/2006/main">
             <a:pPr algn="r">
+              <a:buNone/>
               <a:defRPr sz="900" b="1">
                 <a:solidFill>
                   <a:srgbClr val="9E9FA2"/>
@@ -11058,6 +11202,7 @@
           <a:lstStyle xmlns:a="http://schemas.openxmlformats.org/drawingml/2006/main"/>
           <a:p xmlns:a="http://schemas.openxmlformats.org/drawingml/2006/main">
             <a:pPr algn="r">
+              <a:buNone/>
               <a:defRPr sz="900" b="1">
                 <a:solidFill>
                   <a:srgbClr val="9E9FA2"/>
@@ -11139,6 +11284,7 @@
           <a:lstStyle xmlns:a="http://schemas.openxmlformats.org/drawingml/2006/main"/>
           <a:p xmlns:a="http://schemas.openxmlformats.org/drawingml/2006/main">
             <a:pPr algn="l">
+              <a:buNone/>
               <a:defRPr sz="1275" b="1">
                 <a:solidFill>
                   <a:srgbClr val="00A2EB"/>
@@ -11222,6 +11368,7 @@
           <a:lstStyle xmlns:a="http://schemas.openxmlformats.org/drawingml/2006/main"/>
           <a:p xmlns:a="http://schemas.openxmlformats.org/drawingml/2006/main">
             <a:pPr algn="l">
+              <a:buNone/>
               <a:defRPr sz="1500" b="1">
                 <a:solidFill>
                   <a:srgbClr val="051C2A"/>
@@ -11272,6 +11419,7 @@
           <a:lstStyle xmlns:a="http://schemas.openxmlformats.org/drawingml/2006/main"/>
           <a:p xmlns:a="http://schemas.openxmlformats.org/drawingml/2006/main">
             <a:pPr algn="r">
+              <a:buNone/>
               <a:defRPr sz="1125" b="0">
                 <a:solidFill>
                   <a:srgbClr val="9E9FA2"/>
@@ -11322,6 +11470,7 @@
           <a:lstStyle xmlns:a="http://schemas.openxmlformats.org/drawingml/2006/main"/>
           <a:p xmlns:a="http://schemas.openxmlformats.org/drawingml/2006/main">
             <a:pPr algn="l">
+              <a:buNone/>
               <a:defRPr sz="1275" b="1">
                 <a:solidFill>
                   <a:srgbClr val="373738"/>
@@ -11405,6 +11554,7 @@
           <a:lstStyle xmlns:a="http://schemas.openxmlformats.org/drawingml/2006/main"/>
           <a:p xmlns:a="http://schemas.openxmlformats.org/drawingml/2006/main">
             <a:pPr algn="l">
+              <a:buNone/>
               <a:defRPr sz="1500" b="1">
                 <a:solidFill>
                   <a:srgbClr val="051C2A"/>
@@ -11455,6 +11605,7 @@
           <a:lstStyle xmlns:a="http://schemas.openxmlformats.org/drawingml/2006/main"/>
           <a:p xmlns:a="http://schemas.openxmlformats.org/drawingml/2006/main">
             <a:pPr algn="r">
+              <a:buNone/>
               <a:defRPr sz="1125" b="0">
                 <a:solidFill>
                   <a:srgbClr val="9E9FA2"/>
@@ -11505,6 +11656,7 @@
           <a:lstStyle xmlns:a="http://schemas.openxmlformats.org/drawingml/2006/main"/>
           <a:p xmlns:a="http://schemas.openxmlformats.org/drawingml/2006/main">
             <a:pPr algn="l">
+              <a:buNone/>
               <a:defRPr sz="1275" b="1">
                 <a:solidFill>
                   <a:srgbClr val="373738"/>
@@ -11588,6 +11740,7 @@
           <a:lstStyle xmlns:a="http://schemas.openxmlformats.org/drawingml/2006/main"/>
           <a:p xmlns:a="http://schemas.openxmlformats.org/drawingml/2006/main">
             <a:pPr algn="l">
+              <a:buNone/>
               <a:defRPr sz="1500" b="1">
                 <a:solidFill>
                   <a:srgbClr val="051C2A"/>
@@ -11638,6 +11791,7 @@
           <a:lstStyle xmlns:a="http://schemas.openxmlformats.org/drawingml/2006/main"/>
           <a:p xmlns:a="http://schemas.openxmlformats.org/drawingml/2006/main">
             <a:pPr algn="r">
+              <a:buNone/>
               <a:defRPr sz="1125" b="0">
                 <a:solidFill>
                   <a:srgbClr val="9E9FA2"/>
@@ -11688,6 +11842,7 @@
           <a:lstStyle xmlns:a="http://schemas.openxmlformats.org/drawingml/2006/main"/>
           <a:p xmlns:a="http://schemas.openxmlformats.org/drawingml/2006/main">
             <a:pPr algn="l">
+              <a:buNone/>
               <a:defRPr sz="1275" b="1">
                 <a:solidFill>
                   <a:srgbClr val="373738"/>
@@ -11771,6 +11926,7 @@
           <a:lstStyle xmlns:a="http://schemas.openxmlformats.org/drawingml/2006/main"/>
           <a:p xmlns:a="http://schemas.openxmlformats.org/drawingml/2006/main">
             <a:pPr algn="l">
+              <a:buNone/>
               <a:defRPr sz="1500" b="0">
                 <a:solidFill>
                   <a:srgbClr val="051C2A"/>
@@ -11821,6 +11977,7 @@
           <a:lstStyle xmlns:a="http://schemas.openxmlformats.org/drawingml/2006/main"/>
           <a:p xmlns:a="http://schemas.openxmlformats.org/drawingml/2006/main">
             <a:pPr algn="r">
+              <a:buNone/>
               <a:defRPr sz="1125" b="1">
                 <a:solidFill>
                   <a:srgbClr val="F07D00"/>
@@ -11871,6 +12028,7 @@
           <a:lstStyle xmlns:a="http://schemas.openxmlformats.org/drawingml/2006/main"/>
           <a:p xmlns:a="http://schemas.openxmlformats.org/drawingml/2006/main">
             <a:pPr algn="l">
+              <a:buNone/>
               <a:defRPr sz="1275" b="1">
                 <a:solidFill>
                   <a:srgbClr val="373738"/>
@@ -11954,6 +12112,7 @@
           <a:lstStyle xmlns:a="http://schemas.openxmlformats.org/drawingml/2006/main"/>
           <a:p xmlns:a="http://schemas.openxmlformats.org/drawingml/2006/main">
             <a:pPr algn="l">
+              <a:buNone/>
               <a:defRPr sz="1500" b="1">
                 <a:solidFill>
                   <a:srgbClr val="051C2A"/>
@@ -12004,6 +12163,7 @@
           <a:lstStyle xmlns:a="http://schemas.openxmlformats.org/drawingml/2006/main"/>
           <a:p xmlns:a="http://schemas.openxmlformats.org/drawingml/2006/main">
             <a:pPr algn="r">
+              <a:buNone/>
               <a:defRPr sz="1125" b="0">
                 <a:solidFill>
                   <a:srgbClr val="9E9FA2"/>
@@ -12054,6 +12214,7 @@
           <a:lstStyle xmlns:a="http://schemas.openxmlformats.org/drawingml/2006/main"/>
           <a:p xmlns:a="http://schemas.openxmlformats.org/drawingml/2006/main">
             <a:pPr algn="l">
+              <a:buNone/>
               <a:defRPr sz="1275" b="1">
                 <a:solidFill>
                   <a:srgbClr val="373738"/>
@@ -12137,6 +12298,7 @@
           <a:lstStyle xmlns:a="http://schemas.openxmlformats.org/drawingml/2006/main"/>
           <a:p xmlns:a="http://schemas.openxmlformats.org/drawingml/2006/main">
             <a:pPr algn="l">
+              <a:buNone/>
               <a:defRPr sz="1500" b="1">
                 <a:solidFill>
                   <a:srgbClr val="051C2A"/>
@@ -12187,6 +12349,7 @@
           <a:lstStyle xmlns:a="http://schemas.openxmlformats.org/drawingml/2006/main"/>
           <a:p xmlns:a="http://schemas.openxmlformats.org/drawingml/2006/main">
             <a:pPr algn="r">
+              <a:buNone/>
               <a:defRPr sz="1125" b="0">
                 <a:solidFill>
                   <a:srgbClr val="9E9FA2"/>
@@ -12266,6 +12429,7 @@
           <a:lstStyle xmlns:a="http://schemas.openxmlformats.org/drawingml/2006/main"/>
           <a:p xmlns:a="http://schemas.openxmlformats.org/drawingml/2006/main">
             <a:pPr algn="l">
+              <a:buNone/>
               <a:defRPr sz="1050" b="1">
                 <a:solidFill>
                   <a:srgbClr val="1F40CB"/>
@@ -12316,6 +12480,7 @@
           <a:lstStyle xmlns:a="http://schemas.openxmlformats.org/drawingml/2006/main"/>
           <a:p xmlns:a="http://schemas.openxmlformats.org/drawingml/2006/main">
             <a:pPr algn="l">
+              <a:buNone/>
               <a:defRPr sz="2925" b="1">
                 <a:solidFill>
                   <a:srgbClr val="051C2A"/>
@@ -12428,6 +12593,7 @@
           <a:lstStyle xmlns:a="http://schemas.openxmlformats.org/drawingml/2006/main"/>
           <a:p xmlns:a="http://schemas.openxmlformats.org/drawingml/2006/main">
             <a:pPr algn="l">
+              <a:buNone/>
               <a:defRPr sz="975" b="0">
                 <a:solidFill>
                   <a:srgbClr val="9E9FA2"/>
@@ -12440,7 +12606,7 @@
                   <a:srgbClr val="9E9FA2"/>
                 </a:solidFill>
               </a:rPr>
-              <a:t>FinAI Academy — Arnaud Demes</a:t>
+              <a:t>First Finance - Arnaud Demes</a:t>
             </a:r>
           </a:p>
         </p:txBody>
@@ -12478,6 +12644,7 @@
           <a:lstStyle xmlns:a="http://schemas.openxmlformats.org/drawingml/2006/main"/>
           <a:p xmlns:a="http://schemas.openxmlformats.org/drawingml/2006/main">
             <a:pPr algn="r">
+              <a:buNone/>
               <a:defRPr sz="900" b="1">
                 <a:solidFill>
                   <a:srgbClr val="9E9FA2"/>
@@ -12528,6 +12695,7 @@
           <a:lstStyle xmlns:a="http://schemas.openxmlformats.org/drawingml/2006/main"/>
           <a:p xmlns:a="http://schemas.openxmlformats.org/drawingml/2006/main">
             <a:pPr algn="r">
+              <a:buNone/>
               <a:defRPr sz="900" b="1">
                 <a:solidFill>
                   <a:srgbClr val="9E9FA2"/>
@@ -12609,6 +12777,7 @@
           <a:lstStyle xmlns:a="http://schemas.openxmlformats.org/drawingml/2006/main"/>
           <a:p xmlns:a="http://schemas.openxmlformats.org/drawingml/2006/main">
             <a:pPr algn="l">
+              <a:buNone/>
               <a:defRPr sz="1275" b="1">
                 <a:solidFill>
                   <a:srgbClr val="1F40CB"/>
@@ -12692,6 +12861,7 @@
           <a:lstStyle xmlns:a="http://schemas.openxmlformats.org/drawingml/2006/main"/>
           <a:p xmlns:a="http://schemas.openxmlformats.org/drawingml/2006/main">
             <a:pPr algn="l">
+              <a:buNone/>
               <a:defRPr sz="1500" b="1">
                 <a:solidFill>
                   <a:srgbClr val="051C2A"/>
@@ -12742,6 +12912,7 @@
           <a:lstStyle xmlns:a="http://schemas.openxmlformats.org/drawingml/2006/main"/>
           <a:p xmlns:a="http://schemas.openxmlformats.org/drawingml/2006/main">
             <a:pPr algn="r">
+              <a:buNone/>
               <a:defRPr sz="1125" b="0">
                 <a:solidFill>
                   <a:srgbClr val="9E9FA2"/>
@@ -12792,6 +12963,7 @@
           <a:lstStyle xmlns:a="http://schemas.openxmlformats.org/drawingml/2006/main"/>
           <a:p xmlns:a="http://schemas.openxmlformats.org/drawingml/2006/main">
             <a:pPr algn="l">
+              <a:buNone/>
               <a:defRPr sz="1275" b="1">
                 <a:solidFill>
                   <a:srgbClr val="373738"/>
@@ -12875,6 +13047,7 @@
           <a:lstStyle xmlns:a="http://schemas.openxmlformats.org/drawingml/2006/main"/>
           <a:p xmlns:a="http://schemas.openxmlformats.org/drawingml/2006/main">
             <a:pPr algn="l">
+              <a:buNone/>
               <a:defRPr sz="1500" b="0">
                 <a:solidFill>
                   <a:srgbClr val="051C2A"/>
@@ -12925,6 +13098,7 @@
           <a:lstStyle xmlns:a="http://schemas.openxmlformats.org/drawingml/2006/main"/>
           <a:p xmlns:a="http://schemas.openxmlformats.org/drawingml/2006/main">
             <a:pPr algn="r">
+              <a:buNone/>
               <a:defRPr sz="1125" b="1">
                 <a:solidFill>
                   <a:srgbClr val="F07D00"/>
@@ -12975,6 +13149,7 @@
           <a:lstStyle xmlns:a="http://schemas.openxmlformats.org/drawingml/2006/main"/>
           <a:p xmlns:a="http://schemas.openxmlformats.org/drawingml/2006/main">
             <a:pPr algn="l">
+              <a:buNone/>
               <a:defRPr sz="1275" b="1">
                 <a:solidFill>
                   <a:srgbClr val="373738"/>
@@ -13058,6 +13233,7 @@
           <a:lstStyle xmlns:a="http://schemas.openxmlformats.org/drawingml/2006/main"/>
           <a:p xmlns:a="http://schemas.openxmlformats.org/drawingml/2006/main">
             <a:pPr algn="l">
+              <a:buNone/>
               <a:defRPr sz="1500" b="1">
                 <a:solidFill>
                   <a:srgbClr val="051C2A"/>
@@ -13108,6 +13284,7 @@
           <a:lstStyle xmlns:a="http://schemas.openxmlformats.org/drawingml/2006/main"/>
           <a:p xmlns:a="http://schemas.openxmlformats.org/drawingml/2006/main">
             <a:pPr algn="r">
+              <a:buNone/>
               <a:defRPr sz="1125" b="0">
                 <a:solidFill>
                   <a:srgbClr val="9E9FA2"/>
@@ -13158,6 +13335,7 @@
           <a:lstStyle xmlns:a="http://schemas.openxmlformats.org/drawingml/2006/main"/>
           <a:p xmlns:a="http://schemas.openxmlformats.org/drawingml/2006/main">
             <a:pPr algn="l">
+              <a:buNone/>
               <a:defRPr sz="1275" b="1">
                 <a:solidFill>
                   <a:srgbClr val="373738"/>
@@ -13241,6 +13419,7 @@
           <a:lstStyle xmlns:a="http://schemas.openxmlformats.org/drawingml/2006/main"/>
           <a:p xmlns:a="http://schemas.openxmlformats.org/drawingml/2006/main">
             <a:pPr algn="l">
+              <a:buNone/>
               <a:defRPr sz="1500" b="1">
                 <a:solidFill>
                   <a:srgbClr val="051C2A"/>
@@ -13291,6 +13470,7 @@
           <a:lstStyle xmlns:a="http://schemas.openxmlformats.org/drawingml/2006/main"/>
           <a:p xmlns:a="http://schemas.openxmlformats.org/drawingml/2006/main">
             <a:pPr algn="r">
+              <a:buNone/>
               <a:defRPr sz="1125" b="0">
                 <a:solidFill>
                   <a:srgbClr val="9E9FA2"/>
@@ -13341,6 +13521,7 @@
           <a:lstStyle xmlns:a="http://schemas.openxmlformats.org/drawingml/2006/main"/>
           <a:p xmlns:a="http://schemas.openxmlformats.org/drawingml/2006/main">
             <a:pPr algn="l">
+              <a:buNone/>
               <a:defRPr sz="1275" b="1">
                 <a:solidFill>
                   <a:srgbClr val="373738"/>
@@ -13424,6 +13605,7 @@
           <a:lstStyle xmlns:a="http://schemas.openxmlformats.org/drawingml/2006/main"/>
           <a:p xmlns:a="http://schemas.openxmlformats.org/drawingml/2006/main">
             <a:pPr algn="l">
+              <a:buNone/>
               <a:defRPr sz="1500" b="1">
                 <a:solidFill>
                   <a:srgbClr val="051C2A"/>
@@ -13474,6 +13656,7 @@
           <a:lstStyle xmlns:a="http://schemas.openxmlformats.org/drawingml/2006/main"/>
           <a:p xmlns:a="http://schemas.openxmlformats.org/drawingml/2006/main">
             <a:pPr algn="r">
+              <a:buNone/>
               <a:defRPr sz="1125" b="0">
                 <a:solidFill>
                   <a:srgbClr val="9E9FA2"/>
@@ -13524,6 +13707,7 @@
           <a:lstStyle xmlns:a="http://schemas.openxmlformats.org/drawingml/2006/main"/>
           <a:p xmlns:a="http://schemas.openxmlformats.org/drawingml/2006/main">
             <a:pPr algn="r">
+              <a:buNone/>
               <a:defRPr sz="1875" b="0">
                 <a:solidFill>
                   <a:srgbClr val="051C2A"/>
@@ -13603,6 +13787,7 @@
           <a:lstStyle xmlns:a="http://schemas.openxmlformats.org/drawingml/2006/main"/>
           <a:p xmlns:a="http://schemas.openxmlformats.org/drawingml/2006/main">
             <a:pPr algn="l">
+              <a:buNone/>
               <a:defRPr sz="1050" b="1">
                 <a:solidFill>
                   <a:srgbClr val="1F40CB"/>
@@ -13653,6 +13838,7 @@
           <a:lstStyle xmlns:a="http://schemas.openxmlformats.org/drawingml/2006/main"/>
           <a:p xmlns:a="http://schemas.openxmlformats.org/drawingml/2006/main">
             <a:pPr algn="l">
+              <a:buNone/>
               <a:defRPr sz="2925" b="1">
                 <a:solidFill>
                   <a:srgbClr val="051C2A"/>
@@ -13765,6 +13951,7 @@
           <a:lstStyle xmlns:a="http://schemas.openxmlformats.org/drawingml/2006/main"/>
           <a:p xmlns:a="http://schemas.openxmlformats.org/drawingml/2006/main">
             <a:pPr algn="l">
+              <a:buNone/>
               <a:defRPr sz="975" b="0">
                 <a:solidFill>
                   <a:srgbClr val="9E9FA2"/>
@@ -13777,7 +13964,7 @@
                   <a:srgbClr val="9E9FA2"/>
                 </a:solidFill>
               </a:rPr>
-              <a:t>FinAI Academy — Arnaud Demes</a:t>
+              <a:t>First Finance - Arnaud Demes</a:t>
             </a:r>
           </a:p>
         </p:txBody>
@@ -13815,6 +14002,7 @@
           <a:lstStyle xmlns:a="http://schemas.openxmlformats.org/drawingml/2006/main"/>
           <a:p xmlns:a="http://schemas.openxmlformats.org/drawingml/2006/main">
             <a:pPr algn="r">
+              <a:buNone/>
               <a:defRPr sz="900" b="1">
                 <a:solidFill>
                   <a:srgbClr val="9E9FA2"/>
@@ -13865,6 +14053,7 @@
           <a:lstStyle xmlns:a="http://schemas.openxmlformats.org/drawingml/2006/main"/>
           <a:p xmlns:a="http://schemas.openxmlformats.org/drawingml/2006/main">
             <a:pPr algn="r">
+              <a:buNone/>
               <a:defRPr sz="900" b="1">
                 <a:solidFill>
                   <a:srgbClr val="9E9FA2"/>
@@ -13915,6 +14104,7 @@
           <a:lstStyle xmlns:a="http://schemas.openxmlformats.org/drawingml/2006/main"/>
           <a:p xmlns:a="http://schemas.openxmlformats.org/drawingml/2006/main">
             <a:pPr algn="l">
+              <a:buNone/>
               <a:defRPr sz="1200" b="1">
                 <a:solidFill>
                   <a:srgbClr val="1F40CB"/>
@@ -13965,6 +14155,7 @@
           <a:lstStyle xmlns:a="http://schemas.openxmlformats.org/drawingml/2006/main"/>
           <a:p xmlns:a="http://schemas.openxmlformats.org/drawingml/2006/main">
             <a:pPr algn="l">
+              <a:buNone/>
               <a:defRPr sz="1650" b="1">
                 <a:solidFill>
                   <a:srgbClr val="051C2A"/>
@@ -14046,6 +14237,7 @@
           <a:lstStyle xmlns:a="http://schemas.openxmlformats.org/drawingml/2006/main"/>
           <a:p xmlns:a="http://schemas.openxmlformats.org/drawingml/2006/main">
             <a:pPr algn="l">
+              <a:buNone/>
               <a:defRPr sz="1200" b="1">
                 <a:solidFill>
                   <a:srgbClr val="1F40CB"/>
@@ -14096,6 +14288,7 @@
           <a:lstStyle xmlns:a="http://schemas.openxmlformats.org/drawingml/2006/main"/>
           <a:p xmlns:a="http://schemas.openxmlformats.org/drawingml/2006/main">
             <a:pPr algn="l">
+              <a:buNone/>
               <a:defRPr sz="1650" b="1">
                 <a:solidFill>
                   <a:srgbClr val="051C2A"/>
@@ -14177,6 +14370,7 @@
           <a:lstStyle xmlns:a="http://schemas.openxmlformats.org/drawingml/2006/main"/>
           <a:p xmlns:a="http://schemas.openxmlformats.org/drawingml/2006/main">
             <a:pPr algn="l">
+              <a:buNone/>
               <a:defRPr sz="1200" b="1">
                 <a:solidFill>
                   <a:srgbClr val="1F40CB"/>
@@ -14227,6 +14421,7 @@
           <a:lstStyle xmlns:a="http://schemas.openxmlformats.org/drawingml/2006/main"/>
           <a:p xmlns:a="http://schemas.openxmlformats.org/drawingml/2006/main">
             <a:pPr algn="l">
+              <a:buNone/>
               <a:defRPr sz="1650" b="1">
                 <a:solidFill>
                   <a:srgbClr val="051C2A"/>
@@ -14308,6 +14503,7 @@
           <a:lstStyle xmlns:a="http://schemas.openxmlformats.org/drawingml/2006/main"/>
           <a:p xmlns:a="http://schemas.openxmlformats.org/drawingml/2006/main">
             <a:pPr algn="l">
+              <a:buNone/>
               <a:defRPr sz="1200" b="1">
                 <a:solidFill>
                   <a:srgbClr val="1F40CB"/>
@@ -14358,6 +14554,7 @@
           <a:lstStyle xmlns:a="http://schemas.openxmlformats.org/drawingml/2006/main"/>
           <a:p xmlns:a="http://schemas.openxmlformats.org/drawingml/2006/main">
             <a:pPr algn="l">
+              <a:buNone/>
               <a:defRPr sz="1650" b="1">
                 <a:solidFill>
                   <a:srgbClr val="051C2A"/>
@@ -14439,6 +14636,7 @@
           <a:lstStyle xmlns:a="http://schemas.openxmlformats.org/drawingml/2006/main"/>
           <a:p xmlns:a="http://schemas.openxmlformats.org/drawingml/2006/main">
             <a:pPr algn="l">
+              <a:buNone/>
               <a:defRPr sz="1200" b="1">
                 <a:solidFill>
                   <a:srgbClr val="F07D00"/>
@@ -14489,6 +14687,7 @@
           <a:lstStyle xmlns:a="http://schemas.openxmlformats.org/drawingml/2006/main"/>
           <a:p xmlns:a="http://schemas.openxmlformats.org/drawingml/2006/main">
             <a:pPr algn="l">
+              <a:buNone/>
               <a:defRPr sz="1650" b="1">
                 <a:solidFill>
                   <a:srgbClr val="051C2A"/>
@@ -14599,6 +14798,7 @@
           <a:lstStyle xmlns:a="http://schemas.openxmlformats.org/drawingml/2006/main"/>
           <a:p xmlns:a="http://schemas.openxmlformats.org/drawingml/2006/main">
             <a:pPr algn="l">
+              <a:buNone/>
               <a:defRPr sz="1050" b="1">
                 <a:solidFill>
                   <a:srgbClr val="1F40CB"/>
@@ -14649,6 +14849,7 @@
           <a:lstStyle xmlns:a="http://schemas.openxmlformats.org/drawingml/2006/main"/>
           <a:p xmlns:a="http://schemas.openxmlformats.org/drawingml/2006/main">
             <a:pPr algn="l">
+              <a:buNone/>
               <a:defRPr sz="2925" b="1">
                 <a:solidFill>
                   <a:srgbClr val="051C2A"/>
@@ -14761,6 +14962,7 @@
           <a:lstStyle xmlns:a="http://schemas.openxmlformats.org/drawingml/2006/main"/>
           <a:p xmlns:a="http://schemas.openxmlformats.org/drawingml/2006/main">
             <a:pPr algn="l">
+              <a:buNone/>
               <a:defRPr sz="975" b="0">
                 <a:solidFill>
                   <a:srgbClr val="9E9FA2"/>
@@ -14773,7 +14975,7 @@
                   <a:srgbClr val="9E9FA2"/>
                 </a:solidFill>
               </a:rPr>
-              <a:t>FinAI Academy — Arnaud Demes</a:t>
+              <a:t>First Finance - Arnaud Demes</a:t>
             </a:r>
           </a:p>
         </p:txBody>
@@ -14811,6 +15013,7 @@
           <a:lstStyle xmlns:a="http://schemas.openxmlformats.org/drawingml/2006/main"/>
           <a:p xmlns:a="http://schemas.openxmlformats.org/drawingml/2006/main">
             <a:pPr algn="r">
+              <a:buNone/>
               <a:defRPr sz="900" b="1">
                 <a:solidFill>
                   <a:srgbClr val="9E9FA2"/>
@@ -14861,6 +15064,7 @@
           <a:lstStyle xmlns:a="http://schemas.openxmlformats.org/drawingml/2006/main"/>
           <a:p xmlns:a="http://schemas.openxmlformats.org/drawingml/2006/main">
             <a:pPr algn="r">
+              <a:buNone/>
               <a:defRPr sz="900" b="1">
                 <a:solidFill>
                   <a:srgbClr val="9E9FA2"/>
@@ -14942,6 +15146,7 @@
           <a:lstStyle xmlns:a="http://schemas.openxmlformats.org/drawingml/2006/main"/>
           <a:p xmlns:a="http://schemas.openxmlformats.org/drawingml/2006/main">
             <a:pPr algn="l">
+              <a:buNone/>
               <a:defRPr sz="1275" b="1">
                 <a:solidFill>
                   <a:srgbClr val="00A2EB"/>
@@ -15025,6 +15230,7 @@
           <a:lstStyle xmlns:a="http://schemas.openxmlformats.org/drawingml/2006/main"/>
           <a:p xmlns:a="http://schemas.openxmlformats.org/drawingml/2006/main">
             <a:pPr algn="l">
+              <a:buNone/>
               <a:defRPr sz="1500" b="1">
                 <a:solidFill>
                   <a:srgbClr val="051C2A"/>
@@ -15075,6 +15281,7 @@
           <a:lstStyle xmlns:a="http://schemas.openxmlformats.org/drawingml/2006/main"/>
           <a:p xmlns:a="http://schemas.openxmlformats.org/drawingml/2006/main">
             <a:pPr algn="r">
+              <a:buNone/>
               <a:defRPr sz="1125" b="0">
                 <a:solidFill>
                   <a:srgbClr val="9E9FA2"/>
@@ -15125,6 +15332,7 @@
           <a:lstStyle xmlns:a="http://schemas.openxmlformats.org/drawingml/2006/main"/>
           <a:p xmlns:a="http://schemas.openxmlformats.org/drawingml/2006/main">
             <a:pPr algn="l">
+              <a:buNone/>
               <a:defRPr sz="1275" b="1">
                 <a:solidFill>
                   <a:srgbClr val="373738"/>
@@ -15208,6 +15416,7 @@
           <a:lstStyle xmlns:a="http://schemas.openxmlformats.org/drawingml/2006/main"/>
           <a:p xmlns:a="http://schemas.openxmlformats.org/drawingml/2006/main">
             <a:pPr algn="l">
+              <a:buNone/>
               <a:defRPr sz="1500" b="1">
                 <a:solidFill>
                   <a:srgbClr val="051C2A"/>
@@ -15258,6 +15467,7 @@
           <a:lstStyle xmlns:a="http://schemas.openxmlformats.org/drawingml/2006/main"/>
           <a:p xmlns:a="http://schemas.openxmlformats.org/drawingml/2006/main">
             <a:pPr algn="r">
+              <a:buNone/>
               <a:defRPr sz="1125" b="0">
                 <a:solidFill>
                   <a:srgbClr val="9E9FA2"/>
@@ -15308,6 +15518,7 @@
           <a:lstStyle xmlns:a="http://schemas.openxmlformats.org/drawingml/2006/main"/>
           <a:p xmlns:a="http://schemas.openxmlformats.org/drawingml/2006/main">
             <a:pPr algn="l">
+              <a:buNone/>
               <a:defRPr sz="1275" b="1">
                 <a:solidFill>
                   <a:srgbClr val="373738"/>
@@ -15391,6 +15602,7 @@
           <a:lstStyle xmlns:a="http://schemas.openxmlformats.org/drawingml/2006/main"/>
           <a:p xmlns:a="http://schemas.openxmlformats.org/drawingml/2006/main">
             <a:pPr algn="l">
+              <a:buNone/>
               <a:defRPr sz="1500" b="0">
                 <a:solidFill>
                   <a:srgbClr val="051C2A"/>
@@ -15441,6 +15653,7 @@
           <a:lstStyle xmlns:a="http://schemas.openxmlformats.org/drawingml/2006/main"/>
           <a:p xmlns:a="http://schemas.openxmlformats.org/drawingml/2006/main">
             <a:pPr algn="r">
+              <a:buNone/>
               <a:defRPr sz="1125" b="1">
                 <a:solidFill>
                   <a:srgbClr val="F07D00"/>
@@ -15491,6 +15704,7 @@
           <a:lstStyle xmlns:a="http://schemas.openxmlformats.org/drawingml/2006/main"/>
           <a:p xmlns:a="http://schemas.openxmlformats.org/drawingml/2006/main">
             <a:pPr algn="l">
+              <a:buNone/>
               <a:defRPr sz="1275" b="1">
                 <a:solidFill>
                   <a:srgbClr val="373738"/>
@@ -15574,6 +15788,7 @@
           <a:lstStyle xmlns:a="http://schemas.openxmlformats.org/drawingml/2006/main"/>
           <a:p xmlns:a="http://schemas.openxmlformats.org/drawingml/2006/main">
             <a:pPr algn="l">
+              <a:buNone/>
               <a:defRPr sz="1500" b="1">
                 <a:solidFill>
                   <a:srgbClr val="051C2A"/>
@@ -15624,6 +15839,7 @@
           <a:lstStyle xmlns:a="http://schemas.openxmlformats.org/drawingml/2006/main"/>
           <a:p xmlns:a="http://schemas.openxmlformats.org/drawingml/2006/main">
             <a:pPr algn="r">
+              <a:buNone/>
               <a:defRPr sz="1125" b="0">
                 <a:solidFill>
                   <a:srgbClr val="9E9FA2"/>
@@ -15674,6 +15890,7 @@
           <a:lstStyle xmlns:a="http://schemas.openxmlformats.org/drawingml/2006/main"/>
           <a:p xmlns:a="http://schemas.openxmlformats.org/drawingml/2006/main">
             <a:pPr algn="l">
+              <a:buNone/>
               <a:defRPr sz="1275" b="1">
                 <a:solidFill>
                   <a:srgbClr val="373738"/>
@@ -15757,6 +15974,7 @@
           <a:lstStyle xmlns:a="http://schemas.openxmlformats.org/drawingml/2006/main"/>
           <a:p xmlns:a="http://schemas.openxmlformats.org/drawingml/2006/main">
             <a:pPr algn="l">
+              <a:buNone/>
               <a:defRPr sz="1500" b="1">
                 <a:solidFill>
                   <a:srgbClr val="051C2A"/>
@@ -15807,6 +16025,7 @@
           <a:lstStyle xmlns:a="http://schemas.openxmlformats.org/drawingml/2006/main"/>
           <a:p xmlns:a="http://schemas.openxmlformats.org/drawingml/2006/main">
             <a:pPr algn="r">
+              <a:buNone/>
               <a:defRPr sz="1125" b="0">
                 <a:solidFill>
                   <a:srgbClr val="9E9FA2"/>
@@ -15857,6 +16076,7 @@
           <a:lstStyle xmlns:a="http://schemas.openxmlformats.org/drawingml/2006/main"/>
           <a:p xmlns:a="http://schemas.openxmlformats.org/drawingml/2006/main">
             <a:pPr algn="r">
+              <a:buNone/>
               <a:defRPr sz="1875" b="0">
                 <a:solidFill>
                   <a:srgbClr val="051C2A"/>

</xml_diff>

<commit_message>
content: add the model gateway micro deck
</commit_message>
<xml_diff>
--- a/decks/00-course-introduction.pptx
+++ b/decks/00-course-introduction.pptx
@@ -2,24 +2,24 @@
 <file path=ppt/presentation.xml><?xml version="1.0" encoding="utf-8"?>
 <p:presentation xmlns:p="http://schemas.openxmlformats.org/presentationml/2006/main">
   <p:sldMasterIdLst>
-    <p:sldMasterId xmlns:r="http://schemas.openxmlformats.org/officeDocument/2006/relationships" id="2147483648" r:id="R5925d3c7253f40cc"/>
+    <p:sldMasterId xmlns:r="http://schemas.openxmlformats.org/officeDocument/2006/relationships" id="2147483648" r:id="R8d0e676f12c44320"/>
   </p:sldMasterIdLst>
   <p:notesMasterIdLst>
-    <p:notesMasterId xmlns:r="http://schemas.openxmlformats.org/officeDocument/2006/relationships" r:id="Rdca6dfa62bbb4066"/>
+    <p:notesMasterId xmlns:r="http://schemas.openxmlformats.org/officeDocument/2006/relationships" r:id="Rad7162bedd2f4be5"/>
   </p:notesMasterIdLst>
   <p:sldIdLst>
-    <p:sldId xmlns:r="http://schemas.openxmlformats.org/officeDocument/2006/relationships" id="256" r:id="Reacb34acabb948fe"/>
-    <p:sldId xmlns:r="http://schemas.openxmlformats.org/officeDocument/2006/relationships" id="257" r:id="Ra6fab363ad764251"/>
-    <p:sldId xmlns:r="http://schemas.openxmlformats.org/officeDocument/2006/relationships" id="258" r:id="R9a0f8f9bf42a4c60"/>
-    <p:sldId xmlns:r="http://schemas.openxmlformats.org/officeDocument/2006/relationships" id="259" r:id="R23c004ae62794040"/>
-    <p:sldId xmlns:r="http://schemas.openxmlformats.org/officeDocument/2006/relationships" id="260" r:id="Ra6472fc7b471465d"/>
-    <p:sldId xmlns:r="http://schemas.openxmlformats.org/officeDocument/2006/relationships" id="261" r:id="Rae3d6a6e7664456f"/>
-    <p:sldId xmlns:r="http://schemas.openxmlformats.org/officeDocument/2006/relationships" id="262" r:id="R3662417c4df64e98"/>
-    <p:sldId xmlns:r="http://schemas.openxmlformats.org/officeDocument/2006/relationships" id="263" r:id="R5018f2292dcd4a1e"/>
-    <p:sldId xmlns:r="http://schemas.openxmlformats.org/officeDocument/2006/relationships" id="264" r:id="R853672f8c9234061"/>
-    <p:sldId xmlns:r="http://schemas.openxmlformats.org/officeDocument/2006/relationships" id="265" r:id="Rf9d63c53da004aa8"/>
-    <p:sldId xmlns:r="http://schemas.openxmlformats.org/officeDocument/2006/relationships" id="266" r:id="Ra981567327bd4dd7"/>
-    <p:sldId xmlns:r="http://schemas.openxmlformats.org/officeDocument/2006/relationships" id="267" r:id="Ra2810046195b4ac4"/>
+    <p:sldId xmlns:r="http://schemas.openxmlformats.org/officeDocument/2006/relationships" id="256" r:id="Rcce13ee3244e451e"/>
+    <p:sldId xmlns:r="http://schemas.openxmlformats.org/officeDocument/2006/relationships" id="257" r:id="Rc5985020a94f412e"/>
+    <p:sldId xmlns:r="http://schemas.openxmlformats.org/officeDocument/2006/relationships" id="258" r:id="R4fa1a2e2d4144eeb"/>
+    <p:sldId xmlns:r="http://schemas.openxmlformats.org/officeDocument/2006/relationships" id="259" r:id="R38206c64d06345c5"/>
+    <p:sldId xmlns:r="http://schemas.openxmlformats.org/officeDocument/2006/relationships" id="260" r:id="Re4a3758bca2f4ec9"/>
+    <p:sldId xmlns:r="http://schemas.openxmlformats.org/officeDocument/2006/relationships" id="261" r:id="R06aeacc028684a24"/>
+    <p:sldId xmlns:r="http://schemas.openxmlformats.org/officeDocument/2006/relationships" id="262" r:id="R473c41d3a76c4612"/>
+    <p:sldId xmlns:r="http://schemas.openxmlformats.org/officeDocument/2006/relationships" id="263" r:id="R22b14b71f7564fec"/>
+    <p:sldId xmlns:r="http://schemas.openxmlformats.org/officeDocument/2006/relationships" id="264" r:id="R635dd93e29db4a91"/>
+    <p:sldId xmlns:r="http://schemas.openxmlformats.org/officeDocument/2006/relationships" id="265" r:id="R67687ac7beb945d8"/>
+    <p:sldId xmlns:r="http://schemas.openxmlformats.org/officeDocument/2006/relationships" id="266" r:id="R4d9579db5ec541e3"/>
+    <p:sldId xmlns:r="http://schemas.openxmlformats.org/officeDocument/2006/relationships" id="267" r:id="Rc89a99fc8e3041cc"/>
   </p:sldIdLst>
   <p:sldSz cx="12192000" cy="6858000"/>
   <p:notesSz cx="6858000" cy="9144000"/>
@@ -1486,7 +1486,7 @@
   </p:cSld>
   <p:clrMap bg1="lt1" tx1="dk1" bg2="lt2" tx2="dk2" accent1="accent1" accent2="accent2" accent3="accent3" accent4="accent4" accent5="accent5" accent6="accent6" hlink="hlink" folHlink="folHlink"/>
   <p:sldLayoutIdLst>
-    <p:sldLayoutId xmlns:r="http://schemas.openxmlformats.org/officeDocument/2006/relationships" id="2147483649" r:id="R6340d5ffaae74ac3"/>
+    <p:sldLayoutId xmlns:r="http://schemas.openxmlformats.org/officeDocument/2006/relationships" id="2147483649" r:id="Rbb8e6a4ff4d94554"/>
   </p:sldLayoutIdLst>
   <p:txStyles>
     <p:titleStyle>
@@ -2109,7 +2109,7 @@
                   <a:srgbClr val="00A2EB"/>
                 </a:solidFill>
               </a:rPr>
-              <a:t>FINAI ACADEMY</a:t>
+              <a:t>FIRST FINANCE</a:t>
             </a:r>
           </a:p>
         </p:txBody>

</xml_diff>

<commit_message>
docs: validate day one course alignment
</commit_message>
<xml_diff>
--- a/decks/00-course-introduction.pptx
+++ b/decks/00-course-introduction.pptx
@@ -2,24 +2,24 @@
 <file path=ppt/presentation.xml><?xml version="1.0" encoding="utf-8"?>
 <p:presentation xmlns:p="http://schemas.openxmlformats.org/presentationml/2006/main">
   <p:sldMasterIdLst>
-    <p:sldMasterId xmlns:r="http://schemas.openxmlformats.org/officeDocument/2006/relationships" id="2147483648" r:id="R8d0e676f12c44320"/>
+    <p:sldMasterId xmlns:r="http://schemas.openxmlformats.org/officeDocument/2006/relationships" id="2147483648" r:id="Ra6e194796b684c6d"/>
   </p:sldMasterIdLst>
   <p:notesMasterIdLst>
-    <p:notesMasterId xmlns:r="http://schemas.openxmlformats.org/officeDocument/2006/relationships" r:id="Rad7162bedd2f4be5"/>
+    <p:notesMasterId xmlns:r="http://schemas.openxmlformats.org/officeDocument/2006/relationships" r:id="Rce67fdf1bf6748b7"/>
   </p:notesMasterIdLst>
   <p:sldIdLst>
-    <p:sldId xmlns:r="http://schemas.openxmlformats.org/officeDocument/2006/relationships" id="256" r:id="Rcce13ee3244e451e"/>
-    <p:sldId xmlns:r="http://schemas.openxmlformats.org/officeDocument/2006/relationships" id="257" r:id="Rc5985020a94f412e"/>
-    <p:sldId xmlns:r="http://schemas.openxmlformats.org/officeDocument/2006/relationships" id="258" r:id="R4fa1a2e2d4144eeb"/>
-    <p:sldId xmlns:r="http://schemas.openxmlformats.org/officeDocument/2006/relationships" id="259" r:id="R38206c64d06345c5"/>
-    <p:sldId xmlns:r="http://schemas.openxmlformats.org/officeDocument/2006/relationships" id="260" r:id="Re4a3758bca2f4ec9"/>
-    <p:sldId xmlns:r="http://schemas.openxmlformats.org/officeDocument/2006/relationships" id="261" r:id="R06aeacc028684a24"/>
-    <p:sldId xmlns:r="http://schemas.openxmlformats.org/officeDocument/2006/relationships" id="262" r:id="R473c41d3a76c4612"/>
-    <p:sldId xmlns:r="http://schemas.openxmlformats.org/officeDocument/2006/relationships" id="263" r:id="R22b14b71f7564fec"/>
-    <p:sldId xmlns:r="http://schemas.openxmlformats.org/officeDocument/2006/relationships" id="264" r:id="R635dd93e29db4a91"/>
-    <p:sldId xmlns:r="http://schemas.openxmlformats.org/officeDocument/2006/relationships" id="265" r:id="R67687ac7beb945d8"/>
-    <p:sldId xmlns:r="http://schemas.openxmlformats.org/officeDocument/2006/relationships" id="266" r:id="R4d9579db5ec541e3"/>
-    <p:sldId xmlns:r="http://schemas.openxmlformats.org/officeDocument/2006/relationships" id="267" r:id="Rc89a99fc8e3041cc"/>
+    <p:sldId xmlns:r="http://schemas.openxmlformats.org/officeDocument/2006/relationships" id="256" r:id="R7dac73c13b2f4300"/>
+    <p:sldId xmlns:r="http://schemas.openxmlformats.org/officeDocument/2006/relationships" id="257" r:id="R0f1bac24167f4c50"/>
+    <p:sldId xmlns:r="http://schemas.openxmlformats.org/officeDocument/2006/relationships" id="258" r:id="R8db07da17ab843b1"/>
+    <p:sldId xmlns:r="http://schemas.openxmlformats.org/officeDocument/2006/relationships" id="259" r:id="Rb6e9c28363874fb4"/>
+    <p:sldId xmlns:r="http://schemas.openxmlformats.org/officeDocument/2006/relationships" id="260" r:id="R5a9fa2f3069b424f"/>
+    <p:sldId xmlns:r="http://schemas.openxmlformats.org/officeDocument/2006/relationships" id="261" r:id="R1560228de1e34506"/>
+    <p:sldId xmlns:r="http://schemas.openxmlformats.org/officeDocument/2006/relationships" id="262" r:id="Ra61992b9b7524cfb"/>
+    <p:sldId xmlns:r="http://schemas.openxmlformats.org/officeDocument/2006/relationships" id="263" r:id="Rb6d2f8943bf54239"/>
+    <p:sldId xmlns:r="http://schemas.openxmlformats.org/officeDocument/2006/relationships" id="264" r:id="R9fe487bba7714195"/>
+    <p:sldId xmlns:r="http://schemas.openxmlformats.org/officeDocument/2006/relationships" id="265" r:id="R6dc83afc38dc40ba"/>
+    <p:sldId xmlns:r="http://schemas.openxmlformats.org/officeDocument/2006/relationships" id="266" r:id="R20ae44b8fd36491f"/>
+    <p:sldId xmlns:r="http://schemas.openxmlformats.org/officeDocument/2006/relationships" id="267" r:id="R7da0dc02ec8c42e3"/>
   </p:sldIdLst>
   <p:sldSz cx="12192000" cy="6858000"/>
   <p:notesSz cx="6858000" cy="9144000"/>
@@ -453,12 +453,7 @@
           <a:lstStyle xmlns:a="http://schemas.openxmlformats.org/drawingml/2006/main"/>
           <a:p xmlns:a="http://schemas.openxmlformats.org/drawingml/2006/main">
             <a:r>
-              <a:t>Open with the finished product promise, not a technology inventory.</a:t>
-            </a:r>
-          </a:p>
-          <a:p xmlns:a="http://schemas.openxmlformats.org/drawingml/2006/main">
-            <a:r>
-              <a:t>Explain that every notebook changes the same Financial Analyst Copilot.</a:t>
+              <a:t>Instructor note: use this slide to frame the two-day Financial Analyst Copilot build and the Day 1 progression.</a:t>
             </a:r>
           </a:p>
           <a:p xmlns:a="http://schemas.openxmlformats.org/drawingml/2006/main">
@@ -473,7 +468,22 @@
           </a:p>
           <a:p xmlns:a="http://schemas.openxmlformats.org/drawingml/2006/main">
             <a:r>
-              <a:t>- Internal course source: course.yml and approved two-day design specification.</a:t>
+              <a:t>- course.yml</a:t>
+            </a:r>
+          </a:p>
+          <a:p xmlns:a="http://schemas.openxmlformats.org/drawingml/2006/main">
+            <a:r>
+              <a:t>- docs/program-blueprint.md</a:t>
+            </a:r>
+          </a:p>
+          <a:p xmlns:a="http://schemas.openxmlformats.org/drawingml/2006/main">
+            <a:r>
+              <a:t>- chapters/00-course-introduction.md</a:t>
+            </a:r>
+          </a:p>
+          <a:p xmlns:a="http://schemas.openxmlformats.org/drawingml/2006/main">
+            <a:r>
+              <a:t>[/Sources]</a:t>
             </a:r>
           </a:p>
         </p:txBody>
@@ -543,7 +553,7 @@
           <a:lstStyle xmlns:a="http://schemas.openxmlformats.org/drawingml/2006/main"/>
           <a:p xmlns:a="http://schemas.openxmlformats.org/drawingml/2006/main">
             <a:r>
-              <a:t>The capstone scaffold provides UI and API plumbing. Live work completes and connects the intelligence layer.</a:t>
+              <a:t>Instructor note: use this slide to frame the two-day Financial Analyst Copilot build and the Day 1 progression.</a:t>
             </a:r>
           </a:p>
           <a:p xmlns:a="http://schemas.openxmlformats.org/drawingml/2006/main">
@@ -558,7 +568,22 @@
           </a:p>
           <a:p xmlns:a="http://schemas.openxmlformats.org/drawingml/2006/main">
             <a:r>
-              <a:t>- Internal course source: course.yml and approved two-day design specification.</a:t>
+              <a:t>- course.yml</a:t>
+            </a:r>
+          </a:p>
+          <a:p xmlns:a="http://schemas.openxmlformats.org/drawingml/2006/main">
+            <a:r>
+              <a:t>- docs/program-blueprint.md</a:t>
+            </a:r>
+          </a:p>
+          <a:p xmlns:a="http://schemas.openxmlformats.org/drawingml/2006/main">
+            <a:r>
+              <a:t>- chapters/00-course-introduction.md</a:t>
+            </a:r>
+          </a:p>
+          <a:p xmlns:a="http://schemas.openxmlformats.org/drawingml/2006/main">
+            <a:r>
+              <a:t>[/Sources]</a:t>
             </a:r>
           </a:p>
         </p:txBody>
@@ -628,7 +653,7 @@
           <a:lstStyle xmlns:a="http://schemas.openxmlformats.org/drawingml/2006/main"/>
           <a:p xmlns:a="http://schemas.openxmlformats.org/drawingml/2006/main">
             <a:r>
-              <a:t>Run the provider switch live in Notebook 01. Explain that both paths are tested separately before class.</a:t>
+              <a:t>Instructor note: use this slide to frame the two-day Financial Analyst Copilot build and the Day 1 progression.</a:t>
             </a:r>
           </a:p>
           <a:p xmlns:a="http://schemas.openxmlformats.org/drawingml/2006/main">
@@ -643,7 +668,22 @@
           </a:p>
           <a:p xmlns:a="http://schemas.openxmlformats.org/drawingml/2006/main">
             <a:r>
-              <a:t>- Internal course source: course.yml and approved two-day design specification.</a:t>
+              <a:t>- course.yml</a:t>
+            </a:r>
+          </a:p>
+          <a:p xmlns:a="http://schemas.openxmlformats.org/drawingml/2006/main">
+            <a:r>
+              <a:t>- docs/program-blueprint.md</a:t>
+            </a:r>
+          </a:p>
+          <a:p xmlns:a="http://schemas.openxmlformats.org/drawingml/2006/main">
+            <a:r>
+              <a:t>- chapters/00-course-introduction.md</a:t>
+            </a:r>
+          </a:p>
+          <a:p xmlns:a="http://schemas.openxmlformats.org/drawingml/2006/main">
+            <a:r>
+              <a:t>[/Sources]</a:t>
             </a:r>
           </a:p>
         </p:txBody>
@@ -713,7 +753,7 @@
           <a:lstStyle xmlns:a="http://schemas.openxmlformats.org/drawingml/2006/main"/>
           <a:p xmlns:a="http://schemas.openxmlformats.org/drawingml/2006/main">
             <a:r>
-              <a:t>Transition directly to Notebook 01. The first objective is a provider-neutral model response with measured latency.</a:t>
+              <a:t>Instructor note: use this slide to frame the two-day Financial Analyst Copilot build and the Day 1 progression.</a:t>
             </a:r>
           </a:p>
           <a:p xmlns:a="http://schemas.openxmlformats.org/drawingml/2006/main">
@@ -728,7 +768,22 @@
           </a:p>
           <a:p xmlns:a="http://schemas.openxmlformats.org/drawingml/2006/main">
             <a:r>
-              <a:t>- Internal course source: course.yml and approved two-day design specification.</a:t>
+              <a:t>- course.yml</a:t>
+            </a:r>
+          </a:p>
+          <a:p xmlns:a="http://schemas.openxmlformats.org/drawingml/2006/main">
+            <a:r>
+              <a:t>- docs/program-blueprint.md</a:t>
+            </a:r>
+          </a:p>
+          <a:p xmlns:a="http://schemas.openxmlformats.org/drawingml/2006/main">
+            <a:r>
+              <a:t>- chapters/00-course-introduction.md</a:t>
+            </a:r>
+          </a:p>
+          <a:p xmlns:a="http://schemas.openxmlformats.org/drawingml/2006/main">
+            <a:r>
+              <a:t>[/Sources]</a:t>
             </a:r>
           </a:p>
         </p:txBody>
@@ -798,7 +853,7 @@
           <a:lstStyle xmlns:a="http://schemas.openxmlformats.org/drawingml/2006/main"/>
           <a:p xmlns:a="http://schemas.openxmlformats.org/drawingml/2006/main">
             <a:r>
-              <a:t>Pause on the word inspectable: evidence, calculations, trajectory and evaluation remain visible.</a:t>
+              <a:t>Instructor note: use this slide to frame the two-day Financial Analyst Copilot build and the Day 1 progression.</a:t>
             </a:r>
           </a:p>
           <a:p xmlns:a="http://schemas.openxmlformats.org/drawingml/2006/main">
@@ -813,7 +868,22 @@
           </a:p>
           <a:p xmlns:a="http://schemas.openxmlformats.org/drawingml/2006/main">
             <a:r>
-              <a:t>- Internal course source: course.yml and approved two-day design specification.</a:t>
+              <a:t>- course.yml</a:t>
+            </a:r>
+          </a:p>
+          <a:p xmlns:a="http://schemas.openxmlformats.org/drawingml/2006/main">
+            <a:r>
+              <a:t>- docs/program-blueprint.md</a:t>
+            </a:r>
+          </a:p>
+          <a:p xmlns:a="http://schemas.openxmlformats.org/drawingml/2006/main">
+            <a:r>
+              <a:t>- chapters/00-course-introduction.md</a:t>
+            </a:r>
+          </a:p>
+          <a:p xmlns:a="http://schemas.openxmlformats.org/drawingml/2006/main">
+            <a:r>
+              <a:t>[/Sources]</a:t>
             </a:r>
           </a:p>
         </p:txBody>
@@ -883,12 +953,7 @@
           <a:lstStyle xmlns:a="http://schemas.openxmlformats.org/drawingml/2006/main"/>
           <a:p xmlns:a="http://schemas.openxmlformats.org/drawingml/2006/main">
             <a:r>
-              <a:t>Demonstrate the final interface briefly before explaining its architecture.</a:t>
-            </a:r>
-          </a:p>
-          <a:p xmlns:a="http://schemas.openxmlformats.org/drawingml/2006/main">
-            <a:r>
-              <a:t>State clearly that the application supports research and does not execute trades.</a:t>
+              <a:t>Instructor note: use this slide to frame the two-day Financial Analyst Copilot build and the Day 1 progression.</a:t>
             </a:r>
           </a:p>
           <a:p xmlns:a="http://schemas.openxmlformats.org/drawingml/2006/main">
@@ -903,7 +968,22 @@
           </a:p>
           <a:p xmlns:a="http://schemas.openxmlformats.org/drawingml/2006/main">
             <a:r>
-              <a:t>- Internal course source: course.yml and approved two-day design specification.</a:t>
+              <a:t>- course.yml</a:t>
+            </a:r>
+          </a:p>
+          <a:p xmlns:a="http://schemas.openxmlformats.org/drawingml/2006/main">
+            <a:r>
+              <a:t>- docs/program-blueprint.md</a:t>
+            </a:r>
+          </a:p>
+          <a:p xmlns:a="http://schemas.openxmlformats.org/drawingml/2006/main">
+            <a:r>
+              <a:t>- chapters/00-course-introduction.md</a:t>
+            </a:r>
+          </a:p>
+          <a:p xmlns:a="http://schemas.openxmlformats.org/drawingml/2006/main">
+            <a:r>
+              <a:t>[/Sources]</a:t>
             </a:r>
           </a:p>
         </p:txBody>
@@ -973,7 +1053,7 @@
           <a:lstStyle xmlns:a="http://schemas.openxmlformats.org/drawingml/2006/main"/>
           <a:p xmlns:a="http://schemas.openxmlformats.org/drawingml/2006/main">
             <a:r>
-              <a:t>Use one example per transition: hallucination, long document, dynamic source choice, external capability discovery.</a:t>
+              <a:t>Instructor note: use this slide to frame the two-day Financial Analyst Copilot build and the Day 1 progression.</a:t>
             </a:r>
           </a:p>
           <a:p xmlns:a="http://schemas.openxmlformats.org/drawingml/2006/main">
@@ -988,7 +1068,22 @@
           </a:p>
           <a:p xmlns:a="http://schemas.openxmlformats.org/drawingml/2006/main">
             <a:r>
-              <a:t>- Internal course source: course.yml and approved two-day design specification.</a:t>
+              <a:t>- course.yml</a:t>
+            </a:r>
+          </a:p>
+          <a:p xmlns:a="http://schemas.openxmlformats.org/drawingml/2006/main">
+            <a:r>
+              <a:t>- docs/program-blueprint.md</a:t>
+            </a:r>
+          </a:p>
+          <a:p xmlns:a="http://schemas.openxmlformats.org/drawingml/2006/main">
+            <a:r>
+              <a:t>- chapters/00-course-introduction.md</a:t>
+            </a:r>
+          </a:p>
+          <a:p xmlns:a="http://schemas.openxmlformats.org/drawingml/2006/main">
+            <a:r>
+              <a:t>[/Sources]</a:t>
             </a:r>
           </a:p>
         </p:txBody>
@@ -1058,7 +1153,7 @@
           <a:lstStyle xmlns:a="http://schemas.openxmlformats.org/drawingml/2006/main"/>
           <a:p xmlns:a="http://schemas.openxmlformats.org/drawingml/2006/main">
             <a:r>
-              <a:t>Explain that failure labs are deliberate: the learner sees why the next abstraction exists.</a:t>
+              <a:t>Instructor note: use this slide to frame the two-day Financial Analyst Copilot build and the Day 1 progression.</a:t>
             </a:r>
           </a:p>
           <a:p xmlns:a="http://schemas.openxmlformats.org/drawingml/2006/main">
@@ -1073,7 +1168,22 @@
           </a:p>
           <a:p xmlns:a="http://schemas.openxmlformats.org/drawingml/2006/main">
             <a:r>
-              <a:t>- Internal course source: course.yml and approved two-day design specification.</a:t>
+              <a:t>- course.yml</a:t>
+            </a:r>
+          </a:p>
+          <a:p xmlns:a="http://schemas.openxmlformats.org/drawingml/2006/main">
+            <a:r>
+              <a:t>- docs/program-blueprint.md</a:t>
+            </a:r>
+          </a:p>
+          <a:p xmlns:a="http://schemas.openxmlformats.org/drawingml/2006/main">
+            <a:r>
+              <a:t>- chapters/00-course-introduction.md</a:t>
+            </a:r>
+          </a:p>
+          <a:p xmlns:a="http://schemas.openxmlformats.org/drawingml/2006/main">
+            <a:r>
+              <a:t>[/Sources]</a:t>
             </a:r>
           </a:p>
         </p:txBody>
@@ -1143,12 +1253,7 @@
           <a:lstStyle xmlns:a="http://schemas.openxmlformats.org/drawingml/2006/main"/>
           <a:p xmlns:a="http://schemas.openxmlformats.org/drawingml/2006/main">
             <a:r>
-              <a:t>The learner has already called both provider paths before the first break.</a:t>
-            </a:r>
-          </a:p>
-          <a:p xmlns:a="http://schemas.openxmlformats.org/drawingml/2006/main">
-            <a:r>
-              <a:t>End the morning by making retrieval visible without a framework.</a:t>
+              <a:t>Instructor note: use this slide to frame the two-day Financial Analyst Copilot build and the Day 1 progression.</a:t>
             </a:r>
           </a:p>
           <a:p xmlns:a="http://schemas.openxmlformats.org/drawingml/2006/main">
@@ -1163,7 +1268,22 @@
           </a:p>
           <a:p xmlns:a="http://schemas.openxmlformats.org/drawingml/2006/main">
             <a:r>
-              <a:t>- Internal course source: course.yml and approved two-day design specification.</a:t>
+              <a:t>- course.yml</a:t>
+            </a:r>
+          </a:p>
+          <a:p xmlns:a="http://schemas.openxmlformats.org/drawingml/2006/main">
+            <a:r>
+              <a:t>- docs/program-blueprint.md</a:t>
+            </a:r>
+          </a:p>
+          <a:p xmlns:a="http://schemas.openxmlformats.org/drawingml/2006/main">
+            <a:r>
+              <a:t>- chapters/00-course-introduction.md</a:t>
+            </a:r>
+          </a:p>
+          <a:p xmlns:a="http://schemas.openxmlformats.org/drawingml/2006/main">
+            <a:r>
+              <a:t>[/Sources]</a:t>
             </a:r>
           </a:p>
         </p:txBody>
@@ -1233,7 +1353,7 @@
           <a:lstStyle xmlns:a="http://schemas.openxmlformats.org/drawingml/2006/main"/>
           <a:p xmlns:a="http://schemas.openxmlformats.org/drawingml/2006/main">
             <a:r>
-              <a:t>The long chunking lab is the centre of Day 1. Preserve the comparison time; prebuild parsing boilerplate if required.</a:t>
+              <a:t>Instructor note: use this slide to frame the two-day Financial Analyst Copilot build and the Day 1 progression.</a:t>
             </a:r>
           </a:p>
           <a:p xmlns:a="http://schemas.openxmlformats.org/drawingml/2006/main">
@@ -1248,7 +1368,22 @@
           </a:p>
           <a:p xmlns:a="http://schemas.openxmlformats.org/drawingml/2006/main">
             <a:r>
-              <a:t>- Internal course source: course.yml and approved two-day design specification.</a:t>
+              <a:t>- course.yml</a:t>
+            </a:r>
+          </a:p>
+          <a:p xmlns:a="http://schemas.openxmlformats.org/drawingml/2006/main">
+            <a:r>
+              <a:t>- docs/program-blueprint.md</a:t>
+            </a:r>
+          </a:p>
+          <a:p xmlns:a="http://schemas.openxmlformats.org/drawingml/2006/main">
+            <a:r>
+              <a:t>- chapters/00-course-introduction.md</a:t>
+            </a:r>
+          </a:p>
+          <a:p xmlns:a="http://schemas.openxmlformats.org/drawingml/2006/main">
+            <a:r>
+              <a:t>[/Sources]</a:t>
             </a:r>
           </a:p>
         </p:txBody>
@@ -1318,7 +1453,7 @@
           <a:lstStyle xmlns:a="http://schemas.openxmlformats.org/drawingml/2006/main"/>
           <a:p xmlns:a="http://schemas.openxmlformats.org/drawingml/2006/main">
             <a:r>
-              <a:t>Close Day 1 by inspecting one success and one failure. Do not judge the pipeline only from a polished demo.</a:t>
+              <a:t>Instructor note: use this slide to frame the two-day Financial Analyst Copilot build and the Day 1 progression.</a:t>
             </a:r>
           </a:p>
           <a:p xmlns:a="http://schemas.openxmlformats.org/drawingml/2006/main">
@@ -1333,7 +1468,22 @@
           </a:p>
           <a:p xmlns:a="http://schemas.openxmlformats.org/drawingml/2006/main">
             <a:r>
-              <a:t>- Internal course source: course.yml and approved two-day design specification.</a:t>
+              <a:t>- course.yml</a:t>
+            </a:r>
+          </a:p>
+          <a:p xmlns:a="http://schemas.openxmlformats.org/drawingml/2006/main">
+            <a:r>
+              <a:t>- docs/program-blueprint.md</a:t>
+            </a:r>
+          </a:p>
+          <a:p xmlns:a="http://schemas.openxmlformats.org/drawingml/2006/main">
+            <a:r>
+              <a:t>- chapters/00-course-introduction.md</a:t>
+            </a:r>
+          </a:p>
+          <a:p xmlns:a="http://schemas.openxmlformats.org/drawingml/2006/main">
+            <a:r>
+              <a:t>[/Sources]</a:t>
             </a:r>
           </a:p>
         </p:txBody>
@@ -1403,7 +1553,7 @@
           <a:lstStyle xmlns:a="http://schemas.openxmlformats.org/drawingml/2006/main"/>
           <a:p xmlns:a="http://schemas.openxmlformats.org/drawingml/2006/main">
             <a:r>
-              <a:t>Keep the workflow before agent sequence explicit. Normal Python remains the preferred option for deterministic calculations.</a:t>
+              <a:t>Instructor note: use this slide to frame the two-day Financial Analyst Copilot build and the Day 1 progression.</a:t>
             </a:r>
           </a:p>
           <a:p xmlns:a="http://schemas.openxmlformats.org/drawingml/2006/main">
@@ -1418,7 +1568,22 @@
           </a:p>
           <a:p xmlns:a="http://schemas.openxmlformats.org/drawingml/2006/main">
             <a:r>
-              <a:t>- Internal course source: course.yml and approved two-day design specification.</a:t>
+              <a:t>- course.yml</a:t>
+            </a:r>
+          </a:p>
+          <a:p xmlns:a="http://schemas.openxmlformats.org/drawingml/2006/main">
+            <a:r>
+              <a:t>- docs/program-blueprint.md</a:t>
+            </a:r>
+          </a:p>
+          <a:p xmlns:a="http://schemas.openxmlformats.org/drawingml/2006/main">
+            <a:r>
+              <a:t>- chapters/00-course-introduction.md</a:t>
+            </a:r>
+          </a:p>
+          <a:p xmlns:a="http://schemas.openxmlformats.org/drawingml/2006/main">
+            <a:r>
+              <a:t>[/Sources]</a:t>
             </a:r>
           </a:p>
         </p:txBody>
@@ -1486,7 +1651,7 @@
   </p:cSld>
   <p:clrMap bg1="lt1" tx1="dk1" bg2="lt2" tx2="dk2" accent1="accent1" accent2="accent2" accent3="accent3" accent4="accent4" accent5="accent5" accent6="accent6" hlink="hlink" folHlink="folHlink"/>
   <p:sldLayoutIdLst>
-    <p:sldLayoutId xmlns:r="http://schemas.openxmlformats.org/officeDocument/2006/relationships" id="2147483649" r:id="Rbb8e6a4ff4d94554"/>
+    <p:sldLayoutId xmlns:r="http://schemas.openxmlformats.org/officeDocument/2006/relationships" id="2147483649" r:id="R5bd86590cb1c41a9"/>
   </p:sldLayoutIdLst>
   <p:txStyles>
     <p:titleStyle>
@@ -2280,7 +2445,7 @@
                   <a:srgbClr val="9E9FA2"/>
                 </a:solidFill>
               </a:rPr>
-              <a:t>Arnaud Demes</a:t>
+              <a:t>First Finance - Arnaud Demes</a:t>
             </a:r>
           </a:p>
         </p:txBody>

</xml_diff>

<commit_message>
slides: add Day 1 environment readiness
</commit_message>
<xml_diff>
--- a/decks/00-course-introduction.pptx
+++ b/decks/00-course-introduction.pptx
@@ -2,24 +2,25 @@
 <file path=ppt/presentation.xml><?xml version="1.0" encoding="utf-8"?>
 <p:presentation xmlns:p="http://schemas.openxmlformats.org/presentationml/2006/main">
   <p:sldMasterIdLst>
-    <p:sldMasterId xmlns:r="http://schemas.openxmlformats.org/officeDocument/2006/relationships" id="2147483648" r:id="Ra6e194796b684c6d"/>
+    <p:sldMasterId xmlns:r="http://schemas.openxmlformats.org/officeDocument/2006/relationships" id="2147483648" r:id="R8b245251ffb24b81"/>
   </p:sldMasterIdLst>
   <p:notesMasterIdLst>
-    <p:notesMasterId xmlns:r="http://schemas.openxmlformats.org/officeDocument/2006/relationships" r:id="Rce67fdf1bf6748b7"/>
+    <p:notesMasterId xmlns:r="http://schemas.openxmlformats.org/officeDocument/2006/relationships" r:id="R60234a886bf04a8a"/>
   </p:notesMasterIdLst>
   <p:sldIdLst>
-    <p:sldId xmlns:r="http://schemas.openxmlformats.org/officeDocument/2006/relationships" id="256" r:id="R7dac73c13b2f4300"/>
-    <p:sldId xmlns:r="http://schemas.openxmlformats.org/officeDocument/2006/relationships" id="257" r:id="R0f1bac24167f4c50"/>
-    <p:sldId xmlns:r="http://schemas.openxmlformats.org/officeDocument/2006/relationships" id="258" r:id="R8db07da17ab843b1"/>
-    <p:sldId xmlns:r="http://schemas.openxmlformats.org/officeDocument/2006/relationships" id="259" r:id="Rb6e9c28363874fb4"/>
-    <p:sldId xmlns:r="http://schemas.openxmlformats.org/officeDocument/2006/relationships" id="260" r:id="R5a9fa2f3069b424f"/>
-    <p:sldId xmlns:r="http://schemas.openxmlformats.org/officeDocument/2006/relationships" id="261" r:id="R1560228de1e34506"/>
-    <p:sldId xmlns:r="http://schemas.openxmlformats.org/officeDocument/2006/relationships" id="262" r:id="Ra61992b9b7524cfb"/>
-    <p:sldId xmlns:r="http://schemas.openxmlformats.org/officeDocument/2006/relationships" id="263" r:id="Rb6d2f8943bf54239"/>
-    <p:sldId xmlns:r="http://schemas.openxmlformats.org/officeDocument/2006/relationships" id="264" r:id="R9fe487bba7714195"/>
-    <p:sldId xmlns:r="http://schemas.openxmlformats.org/officeDocument/2006/relationships" id="265" r:id="R6dc83afc38dc40ba"/>
-    <p:sldId xmlns:r="http://schemas.openxmlformats.org/officeDocument/2006/relationships" id="266" r:id="R20ae44b8fd36491f"/>
-    <p:sldId xmlns:r="http://schemas.openxmlformats.org/officeDocument/2006/relationships" id="267" r:id="R7da0dc02ec8c42e3"/>
+    <p:sldId xmlns:r="http://schemas.openxmlformats.org/officeDocument/2006/relationships" id="256" r:id="R1732eceb743a45ae"/>
+    <p:sldId xmlns:r="http://schemas.openxmlformats.org/officeDocument/2006/relationships" id="257" r:id="R4b325fe30d8c4cc9"/>
+    <p:sldId xmlns:r="http://schemas.openxmlformats.org/officeDocument/2006/relationships" id="258" r:id="R922def102f5340d5"/>
+    <p:sldId xmlns:r="http://schemas.openxmlformats.org/officeDocument/2006/relationships" id="259" r:id="R4bc1b83606d840fa"/>
+    <p:sldId xmlns:r="http://schemas.openxmlformats.org/officeDocument/2006/relationships" id="260" r:id="Rd0dd271a46aa4cd5"/>
+    <p:sldId xmlns:r="http://schemas.openxmlformats.org/officeDocument/2006/relationships" id="261" r:id="Rfb33c8e2eb00467c"/>
+    <p:sldId xmlns:r="http://schemas.openxmlformats.org/officeDocument/2006/relationships" id="262" r:id="Re94f816271f44fcb"/>
+    <p:sldId xmlns:r="http://schemas.openxmlformats.org/officeDocument/2006/relationships" id="263" r:id="R54250fc775e7432b"/>
+    <p:sldId xmlns:r="http://schemas.openxmlformats.org/officeDocument/2006/relationships" id="264" r:id="R2e64da8f9d8f4695"/>
+    <p:sldId xmlns:r="http://schemas.openxmlformats.org/officeDocument/2006/relationships" id="265" r:id="R6d7f5e09cdee4ee1"/>
+    <p:sldId xmlns:r="http://schemas.openxmlformats.org/officeDocument/2006/relationships" id="266" r:id="Rc633dd85f16e47d5"/>
+    <p:sldId xmlns:r="http://schemas.openxmlformats.org/officeDocument/2006/relationships" id="267" r:id="R32bfb4aa7356429d"/>
+    <p:sldId xmlns:r="http://schemas.openxmlformats.org/officeDocument/2006/relationships" id="268" r:id="R9b93eebfa7924b42"/>
   </p:sldIdLst>
   <p:sldSz cx="12192000" cy="6858000"/>
   <p:notesSz cx="6858000" cy="9144000"/>
@@ -753,6 +754,101 @@
           <a:lstStyle xmlns:a="http://schemas.openxmlformats.org/drawingml/2006/main"/>
           <a:p xmlns:a="http://schemas.openxmlformats.org/drawingml/2006/main">
             <a:r>
+              <a:t>Confirm the environment before the first live model call.</a:t>
+            </a:r>
+          </a:p>
+          <a:p xmlns:a="http://schemas.openxmlformats.org/drawingml/2006/main">
+            <a:r>
+              <a:t>The written guide contains the complete macOS, Windows, OpenAI and Docker paths.</a:t>
+            </a:r>
+          </a:p>
+          <a:p xmlns:a="http://schemas.openxmlformats.org/drawingml/2006/main">
+            <a:r>
+              <a:t>[Sources]</a:t>
+            </a:r>
+          </a:p>
+          <a:p xmlns:a="http://schemas.openxmlformats.org/drawingml/2006/main">
+            <a:r>
+              <a:t>- Internal course source: docs/getting-started.md</a:t>
+            </a:r>
+          </a:p>
+          <a:p xmlns:a="http://schemas.openxmlformats.org/drawingml/2006/main">
+            <a:r>
+              <a:t>- Internal course source: .env.example</a:t>
+            </a:r>
+          </a:p>
+          <a:p xmlns:a="http://schemas.openxmlformats.org/drawingml/2006/main">
+            <a:r>
+              <a:t>- Internal course source: src/finai_academy/settings.py</a:t>
+            </a:r>
+          </a:p>
+        </p:txBody>
+      </p:sp>
+      <p:sp>
+        <p:nvSpPr>
+          <p:cNvPr id="4" name="Slide Number Placeholder 3"/>
+          <p:cNvSpPr>
+            <a:spLocks xmlns:a="http://schemas.openxmlformats.org/drawingml/2006/main" noGrp="1"/>
+          </p:cNvSpPr>
+          <p:nvPr>
+            <p:ph type="sldNum" idx="5"/>
+          </p:nvPr>
+        </p:nvSpPr>
+        <p:spPr/>
+        <p:txBody>
+          <a:bodyPr xmlns:a="http://schemas.openxmlformats.org/drawingml/2006/main"/>
+          <a:lstStyle xmlns:a="http://schemas.openxmlformats.org/drawingml/2006/main"/>
+          <a:p xmlns:a="http://schemas.openxmlformats.org/drawingml/2006/main"/>
+        </p:txBody>
+      </p:sp>
+    </p:spTree>
+  </p:cSld>
+  <p:clrMapOvr>
+    <a:masterClrMapping xmlns:a="http://schemas.openxmlformats.org/drawingml/2006/main"/>
+  </p:clrMapOvr>
+</p:notes>
+</file>
+
+<file path=ppt/notesSlides/notesSlide13.xml><?xml version="1.0" encoding="utf-8"?>
+<p:notes xmlns:p="http://schemas.openxmlformats.org/presentationml/2006/main">
+  <p:cSld>
+    <p:spTree>
+      <p:nvGrpSpPr>
+        <p:cNvPr id="1" name=""/>
+        <p:cNvGrpSpPr/>
+        <p:nvPr/>
+      </p:nvGrpSpPr>
+      <p:grpSpPr>
+        <a:xfrm xmlns:a="http://schemas.openxmlformats.org/drawingml/2006/main"/>
+      </p:grpSpPr>
+      <p:sp>
+        <p:nvSpPr>
+          <p:cNvPr id="2" name="Slide Image Placeholder 1"/>
+          <p:cNvSpPr>
+            <a:spLocks xmlns:a="http://schemas.openxmlformats.org/drawingml/2006/main" noGrp="1"/>
+          </p:cNvSpPr>
+          <p:nvPr>
+            <p:ph type="sldImg" idx="0"/>
+          </p:nvPr>
+        </p:nvSpPr>
+        <p:spPr/>
+      </p:sp>
+      <p:sp>
+        <p:nvSpPr>
+          <p:cNvPr id="3" name="Notes Placeholder 2"/>
+          <p:cNvSpPr>
+            <a:spLocks xmlns:a="http://schemas.openxmlformats.org/drawingml/2006/main" noGrp="1"/>
+          </p:cNvSpPr>
+          <p:nvPr>
+            <p:ph type="body" idx="1"/>
+          </p:nvPr>
+        </p:nvSpPr>
+        <p:spPr/>
+        <p:txBody>
+          <a:bodyPr xmlns:a="http://schemas.openxmlformats.org/drawingml/2006/main"/>
+          <a:lstStyle xmlns:a="http://schemas.openxmlformats.org/drawingml/2006/main"/>
+          <a:p xmlns:a="http://schemas.openxmlformats.org/drawingml/2006/main">
+            <a:r>
               <a:t>Instructor note: use this slide to frame the two-day Financial Analyst Copilot build and the Day 1 progression.</a:t>
             </a:r>
           </a:p>
@@ -1651,7 +1747,7 @@
   </p:cSld>
   <p:clrMap bg1="lt1" tx1="dk1" bg2="lt2" tx2="dk2" accent1="accent1" accent2="accent2" accent3="accent3" accent4="accent4" accent5="accent5" accent6="accent6" hlink="hlink" folHlink="folHlink"/>
   <p:sldLayoutIdLst>
-    <p:sldLayoutId xmlns:r="http://schemas.openxmlformats.org/officeDocument/2006/relationships" id="2147483649" r:id="R5bd86590cb1c41a9"/>
+    <p:sldLayoutId xmlns:r="http://schemas.openxmlformats.org/officeDocument/2006/relationships" id="2147483649" r:id="R5ddf494be48848af"/>
   </p:sldLayoutIdLst>
   <p:txStyles>
     <p:titleStyle>
@@ -4659,7 +4755,7 @@
                   <a:srgbClr val="1F40CB"/>
                 </a:solidFill>
               </a:rPr>
-              <a:t>CLASS ACCEPTANCE CONTRACT</a:t>
+              <a:t>ENVIRONMENT READY</a:t>
             </a:r>
           </a:p>
         </p:txBody>
@@ -4710,7 +4806,7 @@
                   <a:srgbClr val="051C2A"/>
                 </a:solidFill>
               </a:rPr>
-              <a:t>Expected deliverables and validation criteria</a:t>
+              <a:t>Four checks before opening Lesson 01</a:t>
             </a:r>
           </a:p>
         </p:txBody>
@@ -4874,7 +4970,7 @@
                   <a:srgbClr val="9E9FA2"/>
                 </a:solidFill>
               </a:rPr>
-              <a:t>VALIDATION</a:t>
+              <a:t>SETUP</a:t>
             </a:r>
           </a:p>
         </p:txBody>
@@ -4926,6 +5022,935 @@
                 </a:solidFill>
               </a:rPr>
               <a:t>12</a:t>
+            </a:r>
+          </a:p>
+        </p:txBody>
+      </p:sp>
+      <p:sp>
+        <p:nvSpPr>
+          <p:cNvPr id="8" name="criterion-mark-0">
+            <a:extLst xmlns:a="http://schemas.openxmlformats.org/drawingml/2006/main">
+              <a:ext uri="{FF2B5EF4-FFF2-40B4-BE49-F238E27FC236}">
+                <a16:creationId xmlns:a16="http://schemas.microsoft.com/office/drawing/2014/main" id="{A775919D-ACC1-488B-A8BA-B6664DA20A25}"/>
+              </a:ext>
+            </a:extLst>
+          </p:cNvPr>
+          <p:cNvSpPr>
+            <a:spLocks xmlns:a="http://schemas.openxmlformats.org/drawingml/2006/main" noGrp="1"/>
+          </p:cNvSpPr>
+          <p:nvPr/>
+        </p:nvSpPr>
+        <p:spPr>
+          <a:xfrm xmlns:a="http://schemas.openxmlformats.org/drawingml/2006/main">
+            <a:off x="685800" y="1981200"/>
+            <a:ext cx="76200" cy="533400"/>
+          </a:xfrm>
+          <a:prstGeom xmlns:a="http://schemas.openxmlformats.org/drawingml/2006/main" prst="rect">
+            <a:avLst/>
+          </a:prstGeom>
+          <a:solidFill xmlns:a="http://schemas.openxmlformats.org/drawingml/2006/main">
+            <a:srgbClr val="00A2EB"/>
+          </a:solidFill>
+          <a:ln xmlns:a="http://schemas.openxmlformats.org/drawingml/2006/main" w="0">
+            <a:noFill/>
+            <a:prstDash val="solid"/>
+          </a:ln>
+        </p:spPr>
+      </p:sp>
+      <p:sp>
+        <p:nvSpPr>
+          <p:cNvPr id="9" name="criterion-label-0">
+            <a:extLst xmlns:a="http://schemas.openxmlformats.org/drawingml/2006/main">
+              <a:ext uri="{FF2B5EF4-FFF2-40B4-BE49-F238E27FC236}">
+                <a16:creationId xmlns:a16="http://schemas.microsoft.com/office/drawing/2014/main" id="{6863043A-C667-4818-8D95-54CD5E47D7E8}"/>
+              </a:ext>
+            </a:extLst>
+          </p:cNvPr>
+          <p:cNvSpPr>
+            <a:spLocks xmlns:a="http://schemas.openxmlformats.org/drawingml/2006/main" noGrp="1"/>
+          </p:cNvSpPr>
+          <p:nvPr/>
+        </p:nvSpPr>
+        <p:spPr>
+          <a:xfrm xmlns:a="http://schemas.openxmlformats.org/drawingml/2006/main">
+            <a:off x="1028700" y="1952625"/>
+            <a:ext cx="1666875" cy="266700"/>
+          </a:xfrm>
+          <a:prstGeom xmlns:a="http://schemas.openxmlformats.org/drawingml/2006/main" prst="rect">
+            <a:avLst/>
+          </a:prstGeom>
+          <a:noFill xmlns:a="http://schemas.openxmlformats.org/drawingml/2006/main"/>
+          <a:ln xmlns:a="http://schemas.openxmlformats.org/drawingml/2006/main" w="0">
+            <a:noFill/>
+            <a:prstDash val="solid"/>
+          </a:ln>
+        </p:spPr>
+        <p:txBody>
+          <a:bodyPr xmlns:a="http://schemas.openxmlformats.org/drawingml/2006/main"/>
+          <a:lstStyle xmlns:a="http://schemas.openxmlformats.org/drawingml/2006/main"/>
+          <a:p xmlns:a="http://schemas.openxmlformats.org/drawingml/2006/main">
+            <a:pPr algn="l">
+              <a:buNone/>
+              <a:defRPr sz="1125" b="1">
+                <a:solidFill>
+                  <a:srgbClr val="1F40CB"/>
+                </a:solidFill>
+              </a:defRPr>
+            </a:pPr>
+            <a:r>
+              <a:rPr sz="1125" b="1">
+                <a:solidFill>
+                  <a:srgbClr val="1F40CB"/>
+                </a:solidFill>
+              </a:rPr>
+              <a:t>ENV</a:t>
+            </a:r>
+          </a:p>
+        </p:txBody>
+      </p:sp>
+      <p:sp>
+        <p:nvSpPr>
+          <p:cNvPr id="10" name="criterion-text-0">
+            <a:extLst xmlns:a="http://schemas.openxmlformats.org/drawingml/2006/main">
+              <a:ext uri="{FF2B5EF4-FFF2-40B4-BE49-F238E27FC236}">
+                <a16:creationId xmlns:a16="http://schemas.microsoft.com/office/drawing/2014/main" id="{54F7D259-FE11-4F05-8659-F15408B728F2}"/>
+              </a:ext>
+            </a:extLst>
+          </p:cNvPr>
+          <p:cNvSpPr>
+            <a:spLocks xmlns:a="http://schemas.openxmlformats.org/drawingml/2006/main" noGrp="1"/>
+          </p:cNvSpPr>
+          <p:nvPr/>
+        </p:nvSpPr>
+        <p:spPr>
+          <a:xfrm xmlns:a="http://schemas.openxmlformats.org/drawingml/2006/main">
+            <a:off x="3000375" y="1914525"/>
+            <a:ext cx="7953375" cy="476250"/>
+          </a:xfrm>
+          <a:prstGeom xmlns:a="http://schemas.openxmlformats.org/drawingml/2006/main" prst="rect">
+            <a:avLst/>
+          </a:prstGeom>
+          <a:noFill xmlns:a="http://schemas.openxmlformats.org/drawingml/2006/main"/>
+          <a:ln xmlns:a="http://schemas.openxmlformats.org/drawingml/2006/main" w="0">
+            <a:noFill/>
+            <a:prstDash val="solid"/>
+          </a:ln>
+        </p:spPr>
+        <p:txBody>
+          <a:bodyPr xmlns:a="http://schemas.openxmlformats.org/drawingml/2006/main"/>
+          <a:lstStyle xmlns:a="http://schemas.openxmlformats.org/drawingml/2006/main"/>
+          <a:p xmlns:a="http://schemas.openxmlformats.org/drawingml/2006/main">
+            <a:pPr algn="l">
+              <a:buNone/>
+              <a:defRPr sz="1650" b="1">
+                <a:solidFill>
+                  <a:srgbClr val="051C2A"/>
+                </a:solidFill>
+              </a:defRPr>
+            </a:pPr>
+            <a:r>
+              <a:rPr sz="1650" b="1">
+                <a:solidFill>
+                  <a:srgbClr val="051C2A"/>
+                </a:solidFill>
+              </a:rPr>
+              <a:t>uv sync</a:t>
+            </a:r>
+          </a:p>
+        </p:txBody>
+      </p:sp>
+      <p:sp>
+        <p:nvSpPr>
+          <p:cNvPr id="11" name="criterion-mark-1">
+            <a:extLst xmlns:a="http://schemas.openxmlformats.org/drawingml/2006/main">
+              <a:ext uri="{FF2B5EF4-FFF2-40B4-BE49-F238E27FC236}">
+                <a16:creationId xmlns:a16="http://schemas.microsoft.com/office/drawing/2014/main" id="{8CC64062-4022-4EAC-BF91-AEA76FEA6F07}"/>
+              </a:ext>
+            </a:extLst>
+          </p:cNvPr>
+          <p:cNvSpPr>
+            <a:spLocks xmlns:a="http://schemas.openxmlformats.org/drawingml/2006/main" noGrp="1"/>
+          </p:cNvSpPr>
+          <p:nvPr/>
+        </p:nvSpPr>
+        <p:spPr>
+          <a:xfrm xmlns:a="http://schemas.openxmlformats.org/drawingml/2006/main">
+            <a:off x="685800" y="2857500"/>
+            <a:ext cx="76200" cy="533400"/>
+          </a:xfrm>
+          <a:prstGeom xmlns:a="http://schemas.openxmlformats.org/drawingml/2006/main" prst="rect">
+            <a:avLst/>
+          </a:prstGeom>
+          <a:solidFill xmlns:a="http://schemas.openxmlformats.org/drawingml/2006/main">
+            <a:srgbClr val="00A2EB"/>
+          </a:solidFill>
+          <a:ln xmlns:a="http://schemas.openxmlformats.org/drawingml/2006/main" w="0">
+            <a:noFill/>
+            <a:prstDash val="solid"/>
+          </a:ln>
+        </p:spPr>
+      </p:sp>
+      <p:sp>
+        <p:nvSpPr>
+          <p:cNvPr id="12" name="criterion-label-1">
+            <a:extLst xmlns:a="http://schemas.openxmlformats.org/drawingml/2006/main">
+              <a:ext uri="{FF2B5EF4-FFF2-40B4-BE49-F238E27FC236}">
+                <a16:creationId xmlns:a16="http://schemas.microsoft.com/office/drawing/2014/main" id="{494F4DF2-9A93-4553-8FEE-B28E47606B8C}"/>
+              </a:ext>
+            </a:extLst>
+          </p:cNvPr>
+          <p:cNvSpPr>
+            <a:spLocks xmlns:a="http://schemas.openxmlformats.org/drawingml/2006/main" noGrp="1"/>
+          </p:cNvSpPr>
+          <p:nvPr/>
+        </p:nvSpPr>
+        <p:spPr>
+          <a:xfrm xmlns:a="http://schemas.openxmlformats.org/drawingml/2006/main">
+            <a:off x="1028700" y="2828925"/>
+            <a:ext cx="1666875" cy="266700"/>
+          </a:xfrm>
+          <a:prstGeom xmlns:a="http://schemas.openxmlformats.org/drawingml/2006/main" prst="rect">
+            <a:avLst/>
+          </a:prstGeom>
+          <a:noFill xmlns:a="http://schemas.openxmlformats.org/drawingml/2006/main"/>
+          <a:ln xmlns:a="http://schemas.openxmlformats.org/drawingml/2006/main" w="0">
+            <a:noFill/>
+            <a:prstDash val="solid"/>
+          </a:ln>
+        </p:spPr>
+        <p:txBody>
+          <a:bodyPr xmlns:a="http://schemas.openxmlformats.org/drawingml/2006/main"/>
+          <a:lstStyle xmlns:a="http://schemas.openxmlformats.org/drawingml/2006/main"/>
+          <a:p xmlns:a="http://schemas.openxmlformats.org/drawingml/2006/main">
+            <a:pPr algn="l">
+              <a:buNone/>
+              <a:defRPr sz="1125" b="1">
+                <a:solidFill>
+                  <a:srgbClr val="1F40CB"/>
+                </a:solidFill>
+              </a:defRPr>
+            </a:pPr>
+            <a:r>
+              <a:rPr sz="1125" b="1">
+                <a:solidFill>
+                  <a:srgbClr val="1F40CB"/>
+                </a:solidFill>
+              </a:rPr>
+              <a:t>CHAT</a:t>
+            </a:r>
+          </a:p>
+        </p:txBody>
+      </p:sp>
+      <p:sp>
+        <p:nvSpPr>
+          <p:cNvPr id="13" name="criterion-text-1">
+            <a:extLst xmlns:a="http://schemas.openxmlformats.org/drawingml/2006/main">
+              <a:ext uri="{FF2B5EF4-FFF2-40B4-BE49-F238E27FC236}">
+                <a16:creationId xmlns:a16="http://schemas.microsoft.com/office/drawing/2014/main" id="{B5308B8D-B7F4-4CA8-9926-BF7363C85EAA}"/>
+              </a:ext>
+            </a:extLst>
+          </p:cNvPr>
+          <p:cNvSpPr>
+            <a:spLocks xmlns:a="http://schemas.openxmlformats.org/drawingml/2006/main" noGrp="1"/>
+          </p:cNvSpPr>
+          <p:nvPr/>
+        </p:nvSpPr>
+        <p:spPr>
+          <a:xfrm xmlns:a="http://schemas.openxmlformats.org/drawingml/2006/main">
+            <a:off x="3000375" y="2790825"/>
+            <a:ext cx="7953375" cy="476250"/>
+          </a:xfrm>
+          <a:prstGeom xmlns:a="http://schemas.openxmlformats.org/drawingml/2006/main" prst="rect">
+            <a:avLst/>
+          </a:prstGeom>
+          <a:noFill xmlns:a="http://schemas.openxmlformats.org/drawingml/2006/main"/>
+          <a:ln xmlns:a="http://schemas.openxmlformats.org/drawingml/2006/main" w="0">
+            <a:noFill/>
+            <a:prstDash val="solid"/>
+          </a:ln>
+        </p:spPr>
+        <p:txBody>
+          <a:bodyPr xmlns:a="http://schemas.openxmlformats.org/drawingml/2006/main"/>
+          <a:lstStyle xmlns:a="http://schemas.openxmlformats.org/drawingml/2006/main"/>
+          <a:p xmlns:a="http://schemas.openxmlformats.org/drawingml/2006/main">
+            <a:pPr algn="l">
+              <a:buNone/>
+              <a:defRPr sz="1650" b="1">
+                <a:solidFill>
+                  <a:srgbClr val="051C2A"/>
+                </a:solidFill>
+              </a:defRPr>
+            </a:pPr>
+            <a:r>
+              <a:rPr sz="1650" b="1">
+                <a:solidFill>
+                  <a:srgbClr val="051C2A"/>
+                </a:solidFill>
+              </a:rPr>
+              <a:t>ollama pull qwen3:8b</a:t>
+            </a:r>
+          </a:p>
+        </p:txBody>
+      </p:sp>
+      <p:sp>
+        <p:nvSpPr>
+          <p:cNvPr id="14" name="criterion-mark-2">
+            <a:extLst xmlns:a="http://schemas.openxmlformats.org/drawingml/2006/main">
+              <a:ext uri="{FF2B5EF4-FFF2-40B4-BE49-F238E27FC236}">
+                <a16:creationId xmlns:a16="http://schemas.microsoft.com/office/drawing/2014/main" id="{32DC88C5-FD5B-476B-892E-060EA2D03D01}"/>
+              </a:ext>
+            </a:extLst>
+          </p:cNvPr>
+          <p:cNvSpPr>
+            <a:spLocks xmlns:a="http://schemas.openxmlformats.org/drawingml/2006/main" noGrp="1"/>
+          </p:cNvSpPr>
+          <p:nvPr/>
+        </p:nvSpPr>
+        <p:spPr>
+          <a:xfrm xmlns:a="http://schemas.openxmlformats.org/drawingml/2006/main">
+            <a:off x="685800" y="3733800"/>
+            <a:ext cx="76200" cy="533400"/>
+          </a:xfrm>
+          <a:prstGeom xmlns:a="http://schemas.openxmlformats.org/drawingml/2006/main" prst="rect">
+            <a:avLst/>
+          </a:prstGeom>
+          <a:solidFill xmlns:a="http://schemas.openxmlformats.org/drawingml/2006/main">
+            <a:srgbClr val="F07D00"/>
+          </a:solidFill>
+          <a:ln xmlns:a="http://schemas.openxmlformats.org/drawingml/2006/main" w="0">
+            <a:noFill/>
+            <a:prstDash val="solid"/>
+          </a:ln>
+        </p:spPr>
+      </p:sp>
+      <p:sp>
+        <p:nvSpPr>
+          <p:cNvPr id="15" name="criterion-label-2">
+            <a:extLst xmlns:a="http://schemas.openxmlformats.org/drawingml/2006/main">
+              <a:ext uri="{FF2B5EF4-FFF2-40B4-BE49-F238E27FC236}">
+                <a16:creationId xmlns:a16="http://schemas.microsoft.com/office/drawing/2014/main" id="{9626B817-8CD5-435F-9A03-A666F3E0F921}"/>
+              </a:ext>
+            </a:extLst>
+          </p:cNvPr>
+          <p:cNvSpPr>
+            <a:spLocks xmlns:a="http://schemas.openxmlformats.org/drawingml/2006/main" noGrp="1"/>
+          </p:cNvSpPr>
+          <p:nvPr/>
+        </p:nvSpPr>
+        <p:spPr>
+          <a:xfrm xmlns:a="http://schemas.openxmlformats.org/drawingml/2006/main">
+            <a:off x="1028700" y="3705225"/>
+            <a:ext cx="1666875" cy="266700"/>
+          </a:xfrm>
+          <a:prstGeom xmlns:a="http://schemas.openxmlformats.org/drawingml/2006/main" prst="rect">
+            <a:avLst/>
+          </a:prstGeom>
+          <a:noFill xmlns:a="http://schemas.openxmlformats.org/drawingml/2006/main"/>
+          <a:ln xmlns:a="http://schemas.openxmlformats.org/drawingml/2006/main" w="0">
+            <a:noFill/>
+            <a:prstDash val="solid"/>
+          </a:ln>
+        </p:spPr>
+        <p:txBody>
+          <a:bodyPr xmlns:a="http://schemas.openxmlformats.org/drawingml/2006/main"/>
+          <a:lstStyle xmlns:a="http://schemas.openxmlformats.org/drawingml/2006/main"/>
+          <a:p xmlns:a="http://schemas.openxmlformats.org/drawingml/2006/main">
+            <a:pPr algn="l">
+              <a:buNone/>
+              <a:defRPr sz="1125" b="1">
+                <a:solidFill>
+                  <a:srgbClr val="F07D00"/>
+                </a:solidFill>
+              </a:defRPr>
+            </a:pPr>
+            <a:r>
+              <a:rPr sz="1125" b="1">
+                <a:solidFill>
+                  <a:srgbClr val="F07D00"/>
+                </a:solidFill>
+              </a:rPr>
+              <a:t>EMBED</a:t>
+            </a:r>
+          </a:p>
+        </p:txBody>
+      </p:sp>
+      <p:sp>
+        <p:nvSpPr>
+          <p:cNvPr id="16" name="criterion-text-2">
+            <a:extLst xmlns:a="http://schemas.openxmlformats.org/drawingml/2006/main">
+              <a:ext uri="{FF2B5EF4-FFF2-40B4-BE49-F238E27FC236}">
+                <a16:creationId xmlns:a16="http://schemas.microsoft.com/office/drawing/2014/main" id="{1414FAFF-9C94-438F-8958-E75F92455E4F}"/>
+              </a:ext>
+            </a:extLst>
+          </p:cNvPr>
+          <p:cNvSpPr>
+            <a:spLocks xmlns:a="http://schemas.openxmlformats.org/drawingml/2006/main" noGrp="1"/>
+          </p:cNvSpPr>
+          <p:nvPr/>
+        </p:nvSpPr>
+        <p:spPr>
+          <a:xfrm xmlns:a="http://schemas.openxmlformats.org/drawingml/2006/main">
+            <a:off x="3000375" y="3667125"/>
+            <a:ext cx="7953375" cy="476250"/>
+          </a:xfrm>
+          <a:prstGeom xmlns:a="http://schemas.openxmlformats.org/drawingml/2006/main" prst="rect">
+            <a:avLst/>
+          </a:prstGeom>
+          <a:noFill xmlns:a="http://schemas.openxmlformats.org/drawingml/2006/main"/>
+          <a:ln xmlns:a="http://schemas.openxmlformats.org/drawingml/2006/main" w="0">
+            <a:noFill/>
+            <a:prstDash val="solid"/>
+          </a:ln>
+        </p:spPr>
+        <p:txBody>
+          <a:bodyPr xmlns:a="http://schemas.openxmlformats.org/drawingml/2006/main"/>
+          <a:lstStyle xmlns:a="http://schemas.openxmlformats.org/drawingml/2006/main"/>
+          <a:p xmlns:a="http://schemas.openxmlformats.org/drawingml/2006/main">
+            <a:pPr algn="l">
+              <a:buNone/>
+              <a:defRPr sz="1650" b="1">
+                <a:solidFill>
+                  <a:srgbClr val="051C2A"/>
+                </a:solidFill>
+              </a:defRPr>
+            </a:pPr>
+            <a:r>
+              <a:rPr sz="1650" b="1">
+                <a:solidFill>
+                  <a:srgbClr val="051C2A"/>
+                </a:solidFill>
+              </a:rPr>
+              <a:t>ollama pull qwen3-embedding:0.6b</a:t>
+            </a:r>
+          </a:p>
+        </p:txBody>
+      </p:sp>
+      <p:sp>
+        <p:nvSpPr>
+          <p:cNvPr id="17" name="criterion-mark-3">
+            <a:extLst xmlns:a="http://schemas.openxmlformats.org/drawingml/2006/main">
+              <a:ext uri="{FF2B5EF4-FFF2-40B4-BE49-F238E27FC236}">
+                <a16:creationId xmlns:a16="http://schemas.microsoft.com/office/drawing/2014/main" id="{923699C3-0230-48E6-816A-A16D72BC92B0}"/>
+              </a:ext>
+            </a:extLst>
+          </p:cNvPr>
+          <p:cNvSpPr>
+            <a:spLocks xmlns:a="http://schemas.openxmlformats.org/drawingml/2006/main" noGrp="1"/>
+          </p:cNvSpPr>
+          <p:nvPr/>
+        </p:nvSpPr>
+        <p:spPr>
+          <a:xfrm xmlns:a="http://schemas.openxmlformats.org/drawingml/2006/main">
+            <a:off x="685800" y="4610100"/>
+            <a:ext cx="76200" cy="533400"/>
+          </a:xfrm>
+          <a:prstGeom xmlns:a="http://schemas.openxmlformats.org/drawingml/2006/main" prst="rect">
+            <a:avLst/>
+          </a:prstGeom>
+          <a:solidFill xmlns:a="http://schemas.openxmlformats.org/drawingml/2006/main">
+            <a:srgbClr val="00A2EB"/>
+          </a:solidFill>
+          <a:ln xmlns:a="http://schemas.openxmlformats.org/drawingml/2006/main" w="0">
+            <a:noFill/>
+            <a:prstDash val="solid"/>
+          </a:ln>
+        </p:spPr>
+      </p:sp>
+      <p:sp>
+        <p:nvSpPr>
+          <p:cNvPr id="18" name="criterion-label-3">
+            <a:extLst xmlns:a="http://schemas.openxmlformats.org/drawingml/2006/main">
+              <a:ext uri="{FF2B5EF4-FFF2-40B4-BE49-F238E27FC236}">
+                <a16:creationId xmlns:a16="http://schemas.microsoft.com/office/drawing/2014/main" id="{02D508D9-5349-4A67-8536-17850717B820}"/>
+              </a:ext>
+            </a:extLst>
+          </p:cNvPr>
+          <p:cNvSpPr>
+            <a:spLocks xmlns:a="http://schemas.openxmlformats.org/drawingml/2006/main" noGrp="1"/>
+          </p:cNvSpPr>
+          <p:nvPr/>
+        </p:nvSpPr>
+        <p:spPr>
+          <a:xfrm xmlns:a="http://schemas.openxmlformats.org/drawingml/2006/main">
+            <a:off x="1028700" y="4581525"/>
+            <a:ext cx="1666875" cy="266700"/>
+          </a:xfrm>
+          <a:prstGeom xmlns:a="http://schemas.openxmlformats.org/drawingml/2006/main" prst="rect">
+            <a:avLst/>
+          </a:prstGeom>
+          <a:noFill xmlns:a="http://schemas.openxmlformats.org/drawingml/2006/main"/>
+          <a:ln xmlns:a="http://schemas.openxmlformats.org/drawingml/2006/main" w="0">
+            <a:noFill/>
+            <a:prstDash val="solid"/>
+          </a:ln>
+        </p:spPr>
+        <p:txBody>
+          <a:bodyPr xmlns:a="http://schemas.openxmlformats.org/drawingml/2006/main"/>
+          <a:lstStyle xmlns:a="http://schemas.openxmlformats.org/drawingml/2006/main"/>
+          <a:p xmlns:a="http://schemas.openxmlformats.org/drawingml/2006/main">
+            <a:pPr algn="l">
+              <a:buNone/>
+              <a:defRPr sz="1125" b="1">
+                <a:solidFill>
+                  <a:srgbClr val="1F40CB"/>
+                </a:solidFill>
+              </a:defRPr>
+            </a:pPr>
+            <a:r>
+              <a:rPr sz="1125" b="1">
+                <a:solidFill>
+                  <a:srgbClr val="1F40CB"/>
+                </a:solidFill>
+              </a:rPr>
+              <a:t>VERIFY</a:t>
+            </a:r>
+          </a:p>
+        </p:txBody>
+      </p:sp>
+      <p:sp>
+        <p:nvSpPr>
+          <p:cNvPr id="19" name="criterion-text-3">
+            <a:extLst xmlns:a="http://schemas.openxmlformats.org/drawingml/2006/main">
+              <a:ext uri="{FF2B5EF4-FFF2-40B4-BE49-F238E27FC236}">
+                <a16:creationId xmlns:a16="http://schemas.microsoft.com/office/drawing/2014/main" id="{EA89F2AD-3438-4D0F-A32B-CB15C2C653E7}"/>
+              </a:ext>
+            </a:extLst>
+          </p:cNvPr>
+          <p:cNvSpPr>
+            <a:spLocks xmlns:a="http://schemas.openxmlformats.org/drawingml/2006/main" noGrp="1"/>
+          </p:cNvSpPr>
+          <p:nvPr/>
+        </p:nvSpPr>
+        <p:spPr>
+          <a:xfrm xmlns:a="http://schemas.openxmlformats.org/drawingml/2006/main">
+            <a:off x="3000375" y="4543425"/>
+            <a:ext cx="7953375" cy="476250"/>
+          </a:xfrm>
+          <a:prstGeom xmlns:a="http://schemas.openxmlformats.org/drawingml/2006/main" prst="rect">
+            <a:avLst/>
+          </a:prstGeom>
+          <a:noFill xmlns:a="http://schemas.openxmlformats.org/drawingml/2006/main"/>
+          <a:ln xmlns:a="http://schemas.openxmlformats.org/drawingml/2006/main" w="0">
+            <a:noFill/>
+            <a:prstDash val="solid"/>
+          </a:ln>
+        </p:spPr>
+        <p:txBody>
+          <a:bodyPr xmlns:a="http://schemas.openxmlformats.org/drawingml/2006/main"/>
+          <a:lstStyle xmlns:a="http://schemas.openxmlformats.org/drawingml/2006/main"/>
+          <a:p xmlns:a="http://schemas.openxmlformats.org/drawingml/2006/main">
+            <a:pPr algn="l">
+              <a:buNone/>
+              <a:defRPr sz="1650" b="1">
+                <a:solidFill>
+                  <a:srgbClr val="051C2A"/>
+                </a:solidFill>
+              </a:defRPr>
+            </a:pPr>
+            <a:r>
+              <a:rPr sz="1650" b="1">
+                <a:solidFill>
+                  <a:srgbClr val="051C2A"/>
+                </a:solidFill>
+              </a:rPr>
+              <a:t>scripts/setup_check.py --provider ollama</a:t>
+            </a:r>
+          </a:p>
+        </p:txBody>
+      </p:sp>
+      <p:sp>
+        <p:nvSpPr>
+          <p:cNvPr id="20" name="closing">
+            <a:extLst xmlns:a="http://schemas.openxmlformats.org/drawingml/2006/main">
+              <a:ext uri="{FF2B5EF4-FFF2-40B4-BE49-F238E27FC236}">
+                <a16:creationId xmlns:a16="http://schemas.microsoft.com/office/drawing/2014/main" id="{74B9F64C-2620-4CD3-80E2-1CA9209941D5}"/>
+              </a:ext>
+            </a:extLst>
+          </p:cNvPr>
+          <p:cNvSpPr>
+            <a:spLocks xmlns:a="http://schemas.openxmlformats.org/drawingml/2006/main" noGrp="1"/>
+          </p:cNvSpPr>
+          <p:nvPr/>
+        </p:nvSpPr>
+        <p:spPr>
+          <a:xfrm xmlns:a="http://schemas.openxmlformats.org/drawingml/2006/main">
+            <a:off x="6191250" y="5429250"/>
+            <a:ext cx="4762500" cy="400050"/>
+          </a:xfrm>
+          <a:prstGeom xmlns:a="http://schemas.openxmlformats.org/drawingml/2006/main" prst="rect">
+            <a:avLst/>
+          </a:prstGeom>
+          <a:noFill xmlns:a="http://schemas.openxmlformats.org/drawingml/2006/main"/>
+          <a:ln xmlns:a="http://schemas.openxmlformats.org/drawingml/2006/main" w="0">
+            <a:noFill/>
+            <a:prstDash val="solid"/>
+          </a:ln>
+        </p:spPr>
+        <p:txBody>
+          <a:bodyPr xmlns:a="http://schemas.openxmlformats.org/drawingml/2006/main"/>
+          <a:lstStyle xmlns:a="http://schemas.openxmlformats.org/drawingml/2006/main"/>
+          <a:p xmlns:a="http://schemas.openxmlformats.org/drawingml/2006/main">
+            <a:pPr algn="r">
+              <a:buNone/>
+              <a:defRPr sz="2175" b="1">
+                <a:solidFill>
+                  <a:srgbClr val="051C2A"/>
+                </a:solidFill>
+              </a:defRPr>
+            </a:pPr>
+            <a:r>
+              <a:rPr sz="2175" b="1">
+                <a:solidFill>
+                  <a:srgbClr val="051C2A"/>
+                </a:solidFill>
+              </a:rPr>
+              <a:t>START  01_model_gateway.ipynb</a:t>
+            </a:r>
+          </a:p>
+        </p:txBody>
+      </p:sp>
+    </p:spTree>
+    <p:extLst>
+      <p:ext uri="{BB962C8B-B14F-4D97-AF65-F5344CB8AC3E}">
+        <p14:creationId xmlns:p14="http://schemas.microsoft.com/office/powerpoint/2010/main" val="585714637"/>
+      </p:ext>
+    </p:extLst>
+  </p:cSld>
+</p:sld>
+</file>
+
+<file path=ppt/slides/slide13.xml><?xml version="1.0" encoding="utf-8"?>
+<p:sld xmlns:p="http://schemas.openxmlformats.org/presentationml/2006/main">
+  <p:cSld>
+    <p:bg>
+      <p:bgPr>
+        <a:solidFill xmlns:a="http://schemas.openxmlformats.org/drawingml/2006/main">
+          <a:srgbClr val="F5F5F5"/>
+        </a:solidFill>
+      </p:bgPr>
+    </p:bg>
+    <p:spTree>
+      <p:nvGrpSpPr>
+        <p:cNvPr id="1" name=""/>
+        <p:cNvGrpSpPr/>
+        <p:nvPr/>
+      </p:nvGrpSpPr>
+      <p:grpSpPr>
+        <a:xfrm xmlns:a="http://schemas.openxmlformats.org/drawingml/2006/main"/>
+      </p:grpSpPr>
+      <p:sp>
+        <p:nvSpPr>
+          <p:cNvPr id="21" name="kicker-12">
+            <a:extLst xmlns:a="http://schemas.openxmlformats.org/drawingml/2006/main">
+              <a:ext uri="{FF2B5EF4-FFF2-40B4-BE49-F238E27FC236}">
+                <a16:creationId xmlns:a16="http://schemas.microsoft.com/office/drawing/2014/main" id="{28A461CE-0497-48C1-9780-04064A88ADF3}"/>
+              </a:ext>
+            </a:extLst>
+          </p:cNvPr>
+          <p:cNvSpPr>
+            <a:spLocks xmlns:a="http://schemas.openxmlformats.org/drawingml/2006/main" noGrp="1"/>
+          </p:cNvSpPr>
+          <p:nvPr/>
+        </p:nvSpPr>
+        <p:spPr>
+          <a:xfrm xmlns:a="http://schemas.openxmlformats.org/drawingml/2006/main">
+            <a:off x="685800" y="514350"/>
+            <a:ext cx="4762500" cy="228600"/>
+          </a:xfrm>
+          <a:prstGeom xmlns:a="http://schemas.openxmlformats.org/drawingml/2006/main" prst="rect">
+            <a:avLst/>
+          </a:prstGeom>
+          <a:noFill xmlns:a="http://schemas.openxmlformats.org/drawingml/2006/main"/>
+          <a:ln xmlns:a="http://schemas.openxmlformats.org/drawingml/2006/main" w="0">
+            <a:noFill/>
+            <a:prstDash val="solid"/>
+          </a:ln>
+        </p:spPr>
+        <p:txBody>
+          <a:bodyPr xmlns:a="http://schemas.openxmlformats.org/drawingml/2006/main"/>
+          <a:lstStyle xmlns:a="http://schemas.openxmlformats.org/drawingml/2006/main"/>
+          <a:p xmlns:a="http://schemas.openxmlformats.org/drawingml/2006/main">
+            <a:pPr algn="l">
+              <a:buNone/>
+              <a:defRPr sz="1050" b="1">
+                <a:solidFill>
+                  <a:srgbClr val="1F40CB"/>
+                </a:solidFill>
+              </a:defRPr>
+            </a:pPr>
+            <a:r>
+              <a:rPr sz="1050" b="1">
+                <a:solidFill>
+                  <a:srgbClr val="1F40CB"/>
+                </a:solidFill>
+              </a:rPr>
+              <a:t>CLASS ACCEPTANCE CONTRACT</a:t>
+            </a:r>
+          </a:p>
+        </p:txBody>
+      </p:sp>
+      <p:sp>
+        <p:nvSpPr>
+          <p:cNvPr id="2" name="title-12">
+            <a:extLst xmlns:a="http://schemas.openxmlformats.org/drawingml/2006/main">
+              <a:ext uri="{FF2B5EF4-FFF2-40B4-BE49-F238E27FC236}">
+                <a16:creationId xmlns:a16="http://schemas.microsoft.com/office/drawing/2014/main" id="{34974457-B792-4D9D-9294-0A71D7FF8514}"/>
+              </a:ext>
+            </a:extLst>
+          </p:cNvPr>
+          <p:cNvSpPr>
+            <a:spLocks xmlns:a="http://schemas.openxmlformats.org/drawingml/2006/main" noGrp="1"/>
+          </p:cNvSpPr>
+          <p:nvPr/>
+        </p:nvSpPr>
+        <p:spPr>
+          <a:xfrm xmlns:a="http://schemas.openxmlformats.org/drawingml/2006/main">
+            <a:off x="685800" y="866775"/>
+            <a:ext cx="10572750" cy="876300"/>
+          </a:xfrm>
+          <a:prstGeom xmlns:a="http://schemas.openxmlformats.org/drawingml/2006/main" prst="rect">
+            <a:avLst/>
+          </a:prstGeom>
+          <a:noFill xmlns:a="http://schemas.openxmlformats.org/drawingml/2006/main"/>
+          <a:ln xmlns:a="http://schemas.openxmlformats.org/drawingml/2006/main" w="0">
+            <a:noFill/>
+            <a:prstDash val="solid"/>
+          </a:ln>
+        </p:spPr>
+        <p:txBody>
+          <a:bodyPr xmlns:a="http://schemas.openxmlformats.org/drawingml/2006/main"/>
+          <a:lstStyle xmlns:a="http://schemas.openxmlformats.org/drawingml/2006/main"/>
+          <a:p xmlns:a="http://schemas.openxmlformats.org/drawingml/2006/main">
+            <a:pPr algn="l">
+              <a:buNone/>
+              <a:defRPr sz="2925" b="1">
+                <a:solidFill>
+                  <a:srgbClr val="051C2A"/>
+                </a:solidFill>
+              </a:defRPr>
+            </a:pPr>
+            <a:r>
+              <a:rPr sz="2925" b="1">
+                <a:solidFill>
+                  <a:srgbClr val="051C2A"/>
+                </a:solidFill>
+              </a:rPr>
+              <a:t>Expected deliverables and validation criteria</a:t>
+            </a:r>
+          </a:p>
+        </p:txBody>
+      </p:sp>
+      <p:sp>
+        <p:nvSpPr>
+          <p:cNvPr id="3" name="progress-12">
+            <a:extLst xmlns:a="http://schemas.openxmlformats.org/drawingml/2006/main">
+              <a:ext uri="{FF2B5EF4-FFF2-40B4-BE49-F238E27FC236}">
+                <a16:creationId xmlns:a16="http://schemas.microsoft.com/office/drawing/2014/main" id="{05FD0E1C-7850-47A1-B153-D86F16670DDE}"/>
+              </a:ext>
+            </a:extLst>
+          </p:cNvPr>
+          <p:cNvSpPr>
+            <a:spLocks xmlns:a="http://schemas.openxmlformats.org/drawingml/2006/main" noGrp="1"/>
+          </p:cNvSpPr>
+          <p:nvPr/>
+        </p:nvSpPr>
+        <p:spPr>
+          <a:xfrm xmlns:a="http://schemas.openxmlformats.org/drawingml/2006/main">
+            <a:off x="685800" y="6334125"/>
+            <a:ext cx="10820400" cy="19050"/>
+          </a:xfrm>
+          <a:prstGeom xmlns:a="http://schemas.openxmlformats.org/drawingml/2006/main" prst="rect">
+            <a:avLst/>
+          </a:prstGeom>
+          <a:solidFill xmlns:a="http://schemas.openxmlformats.org/drawingml/2006/main">
+            <a:srgbClr val="E5E7E9"/>
+          </a:solidFill>
+          <a:ln xmlns:a="http://schemas.openxmlformats.org/drawingml/2006/main" w="0">
+            <a:noFill/>
+            <a:prstDash val="solid"/>
+          </a:ln>
+        </p:spPr>
+      </p:sp>
+      <p:sp>
+        <p:nvSpPr>
+          <p:cNvPr id="4" name="progress-active-12">
+            <a:extLst xmlns:a="http://schemas.openxmlformats.org/drawingml/2006/main">
+              <a:ext uri="{FF2B5EF4-FFF2-40B4-BE49-F238E27FC236}">
+                <a16:creationId xmlns:a16="http://schemas.microsoft.com/office/drawing/2014/main" id="{F2145F74-0FCC-40D9-9033-CACABF9F6931}"/>
+              </a:ext>
+            </a:extLst>
+          </p:cNvPr>
+          <p:cNvSpPr>
+            <a:spLocks xmlns:a="http://schemas.openxmlformats.org/drawingml/2006/main" noGrp="1"/>
+          </p:cNvSpPr>
+          <p:nvPr/>
+        </p:nvSpPr>
+        <p:spPr>
+          <a:xfrm xmlns:a="http://schemas.openxmlformats.org/drawingml/2006/main">
+            <a:off x="685800" y="6334125"/>
+            <a:ext cx="10820400" cy="19050"/>
+          </a:xfrm>
+          <a:prstGeom xmlns:a="http://schemas.openxmlformats.org/drawingml/2006/main" prst="rect">
+            <a:avLst/>
+          </a:prstGeom>
+          <a:solidFill xmlns:a="http://schemas.openxmlformats.org/drawingml/2006/main">
+            <a:srgbClr val="00A2EB"/>
+          </a:solidFill>
+          <a:ln xmlns:a="http://schemas.openxmlformats.org/drawingml/2006/main" w="0">
+            <a:noFill/>
+            <a:prstDash val="solid"/>
+          </a:ln>
+        </p:spPr>
+      </p:sp>
+      <p:sp>
+        <p:nvSpPr>
+          <p:cNvPr id="5" name="footer-12">
+            <a:extLst xmlns:a="http://schemas.openxmlformats.org/drawingml/2006/main">
+              <a:ext uri="{FF2B5EF4-FFF2-40B4-BE49-F238E27FC236}">
+                <a16:creationId xmlns:a16="http://schemas.microsoft.com/office/drawing/2014/main" id="{A0C6F80E-C7AD-453B-8D57-BF913E143BA6}"/>
+              </a:ext>
+            </a:extLst>
+          </p:cNvPr>
+          <p:cNvSpPr>
+            <a:spLocks xmlns:a="http://schemas.openxmlformats.org/drawingml/2006/main" noGrp="1"/>
+          </p:cNvSpPr>
+          <p:nvPr/>
+        </p:nvSpPr>
+        <p:spPr>
+          <a:xfrm xmlns:a="http://schemas.openxmlformats.org/drawingml/2006/main">
+            <a:off x="685800" y="6477000"/>
+            <a:ext cx="3619500" cy="171450"/>
+          </a:xfrm>
+          <a:prstGeom xmlns:a="http://schemas.openxmlformats.org/drawingml/2006/main" prst="rect">
+            <a:avLst/>
+          </a:prstGeom>
+          <a:noFill xmlns:a="http://schemas.openxmlformats.org/drawingml/2006/main"/>
+          <a:ln xmlns:a="http://schemas.openxmlformats.org/drawingml/2006/main" w="0">
+            <a:noFill/>
+            <a:prstDash val="solid"/>
+          </a:ln>
+        </p:spPr>
+        <p:txBody>
+          <a:bodyPr xmlns:a="http://schemas.openxmlformats.org/drawingml/2006/main"/>
+          <a:lstStyle xmlns:a="http://schemas.openxmlformats.org/drawingml/2006/main"/>
+          <a:p xmlns:a="http://schemas.openxmlformats.org/drawingml/2006/main">
+            <a:pPr algn="l">
+              <a:buNone/>
+              <a:defRPr sz="975" b="0">
+                <a:solidFill>
+                  <a:srgbClr val="9E9FA2"/>
+                </a:solidFill>
+              </a:defRPr>
+            </a:pPr>
+            <a:r>
+              <a:rPr sz="975" b="0">
+                <a:solidFill>
+                  <a:srgbClr val="9E9FA2"/>
+                </a:solidFill>
+              </a:rPr>
+              <a:t>First Finance - Arnaud Demes</a:t>
+            </a:r>
+          </a:p>
+        </p:txBody>
+      </p:sp>
+      <p:sp>
+        <p:nvSpPr>
+          <p:cNvPr id="6" name="section-12">
+            <a:extLst xmlns:a="http://schemas.openxmlformats.org/drawingml/2006/main">
+              <a:ext uri="{FF2B5EF4-FFF2-40B4-BE49-F238E27FC236}">
+                <a16:creationId xmlns:a16="http://schemas.microsoft.com/office/drawing/2014/main" id="{472FCEDA-FAB2-423B-BB7A-D8B8B5FCB7A8}"/>
+              </a:ext>
+            </a:extLst>
+          </p:cNvPr>
+          <p:cNvSpPr>
+            <a:spLocks xmlns:a="http://schemas.openxmlformats.org/drawingml/2006/main" noGrp="1"/>
+          </p:cNvSpPr>
+          <p:nvPr/>
+        </p:nvSpPr>
+        <p:spPr>
+          <a:xfrm xmlns:a="http://schemas.openxmlformats.org/drawingml/2006/main">
+            <a:off x="8286750" y="6477000"/>
+            <a:ext cx="2571750" cy="171450"/>
+          </a:xfrm>
+          <a:prstGeom xmlns:a="http://schemas.openxmlformats.org/drawingml/2006/main" prst="rect">
+            <a:avLst/>
+          </a:prstGeom>
+          <a:noFill xmlns:a="http://schemas.openxmlformats.org/drawingml/2006/main"/>
+          <a:ln xmlns:a="http://schemas.openxmlformats.org/drawingml/2006/main" w="0">
+            <a:noFill/>
+            <a:prstDash val="solid"/>
+          </a:ln>
+        </p:spPr>
+        <p:txBody>
+          <a:bodyPr xmlns:a="http://schemas.openxmlformats.org/drawingml/2006/main"/>
+          <a:lstStyle xmlns:a="http://schemas.openxmlformats.org/drawingml/2006/main"/>
+          <a:p xmlns:a="http://schemas.openxmlformats.org/drawingml/2006/main">
+            <a:pPr algn="r">
+              <a:buNone/>
+              <a:defRPr sz="900" b="1">
+                <a:solidFill>
+                  <a:srgbClr val="9E9FA2"/>
+                </a:solidFill>
+              </a:defRPr>
+            </a:pPr>
+            <a:r>
+              <a:rPr sz="900" b="1">
+                <a:solidFill>
+                  <a:srgbClr val="9E9FA2"/>
+                </a:solidFill>
+              </a:rPr>
+              <a:t>VALIDATION</a:t>
+            </a:r>
+          </a:p>
+        </p:txBody>
+      </p:sp>
+      <p:sp>
+        <p:nvSpPr>
+          <p:cNvPr id="7" name="page-12">
+            <a:extLst xmlns:a="http://schemas.openxmlformats.org/drawingml/2006/main">
+              <a:ext uri="{FF2B5EF4-FFF2-40B4-BE49-F238E27FC236}">
+                <a16:creationId xmlns:a16="http://schemas.microsoft.com/office/drawing/2014/main" id="{95F5B293-0BAD-42B8-9526-F1F194950C79}"/>
+              </a:ext>
+            </a:extLst>
+          </p:cNvPr>
+          <p:cNvSpPr>
+            <a:spLocks xmlns:a="http://schemas.openxmlformats.org/drawingml/2006/main" noGrp="1"/>
+          </p:cNvSpPr>
+          <p:nvPr/>
+        </p:nvSpPr>
+        <p:spPr>
+          <a:xfrm xmlns:a="http://schemas.openxmlformats.org/drawingml/2006/main">
+            <a:off x="11001375" y="6477000"/>
+            <a:ext cx="495300" cy="171450"/>
+          </a:xfrm>
+          <a:prstGeom xmlns:a="http://schemas.openxmlformats.org/drawingml/2006/main" prst="rect">
+            <a:avLst/>
+          </a:prstGeom>
+          <a:noFill xmlns:a="http://schemas.openxmlformats.org/drawingml/2006/main"/>
+          <a:ln xmlns:a="http://schemas.openxmlformats.org/drawingml/2006/main" w="0">
+            <a:noFill/>
+            <a:prstDash val="solid"/>
+          </a:ln>
+        </p:spPr>
+        <p:txBody>
+          <a:bodyPr xmlns:a="http://schemas.openxmlformats.org/drawingml/2006/main"/>
+          <a:lstStyle xmlns:a="http://schemas.openxmlformats.org/drawingml/2006/main"/>
+          <a:p xmlns:a="http://schemas.openxmlformats.org/drawingml/2006/main">
+            <a:pPr algn="r">
+              <a:buNone/>
+              <a:defRPr sz="900" b="1">
+                <a:solidFill>
+                  <a:srgbClr val="9E9FA2"/>
+                </a:solidFill>
+              </a:defRPr>
+            </a:pPr>
+            <a:r>
+              <a:rPr sz="900" b="1">
+                <a:solidFill>
+                  <a:srgbClr val="9E9FA2"/>
+                </a:solidFill>
+              </a:rPr>
+              <a:t>13</a:t>
             </a:r>
           </a:p>
         </p:txBody>

</xml_diff>